<commit_message>
docs: update presentation slides with user version (pptx & pdf)
</commit_message>
<xml_diff>
--- a/docs/HWNet_Presentation.pptx
+++ b/docs/HWNet_Presentation.pptx
@@ -142,8 +142,8 @@
         </p:nvSpPr>
         <p:spPr>
           <a:xfrm>
-            <a:off x="685800" y="2130425"/>
-            <a:ext cx="7772400" cy="1470025"/>
+            <a:off x="914377" y="2130425"/>
+            <a:ext cx="10362940" cy="1470025"/>
           </a:xfrm>
         </p:spPr>
         <p:txBody>
@@ -170,8 +170,8 @@
         </p:nvSpPr>
         <p:spPr>
           <a:xfrm>
-            <a:off x="1371600" y="3886200"/>
-            <a:ext cx="6400800" cy="1752600"/>
+            <a:off x="1828754" y="3886200"/>
+            <a:ext cx="8534186" cy="1752600"/>
           </a:xfrm>
         </p:spPr>
         <p:txBody>
@@ -554,8 +554,8 @@
         </p:nvSpPr>
         <p:spPr>
           <a:xfrm>
-            <a:off x="6629400" y="274638"/>
-            <a:ext cx="2057400" cy="5851525"/>
+            <a:off x="8838978" y="274638"/>
+            <a:ext cx="2743131" cy="5851525"/>
           </a:xfrm>
         </p:spPr>
         <p:txBody>
@@ -582,8 +582,8 @@
         </p:nvSpPr>
         <p:spPr>
           <a:xfrm>
-            <a:off x="457200" y="274638"/>
-            <a:ext cx="6019800" cy="5851525"/>
+            <a:off x="609584" y="274638"/>
+            <a:ext cx="8026199" cy="5851525"/>
           </a:xfrm>
         </p:spPr>
         <p:txBody>
@@ -904,8 +904,8 @@
         </p:nvSpPr>
         <p:spPr>
           <a:xfrm>
-            <a:off x="722313" y="4406900"/>
-            <a:ext cx="7772400" cy="1362075"/>
+            <a:off x="963059" y="4406900"/>
+            <a:ext cx="10362940" cy="1362075"/>
           </a:xfrm>
         </p:spPr>
         <p:txBody>
@@ -936,8 +936,8 @@
         </p:nvSpPr>
         <p:spPr>
           <a:xfrm>
-            <a:off x="722313" y="2906713"/>
-            <a:ext cx="7772400" cy="1500187"/>
+            <a:off x="963059" y="2906713"/>
+            <a:ext cx="10362940" cy="1500187"/>
           </a:xfrm>
         </p:spPr>
         <p:txBody>
@@ -1173,8 +1173,8 @@
         </p:nvSpPr>
         <p:spPr>
           <a:xfrm>
-            <a:off x="457200" y="1600200"/>
-            <a:ext cx="4038600" cy="4525963"/>
+            <a:off x="609584" y="1600200"/>
+            <a:ext cx="5384665" cy="4525963"/>
           </a:xfrm>
         </p:spPr>
         <p:txBody>
@@ -1258,8 +1258,8 @@
         </p:nvSpPr>
         <p:spPr>
           <a:xfrm>
-            <a:off x="4648200" y="1600200"/>
-            <a:ext cx="4038600" cy="4525963"/>
+            <a:off x="6197444" y="1600200"/>
+            <a:ext cx="5384665" cy="4525963"/>
           </a:xfrm>
         </p:spPr>
         <p:txBody>
@@ -1465,8 +1465,8 @@
         </p:nvSpPr>
         <p:spPr>
           <a:xfrm>
-            <a:off x="457200" y="1535113"/>
-            <a:ext cx="4040188" cy="639762"/>
+            <a:off x="609584" y="1535113"/>
+            <a:ext cx="5386782" cy="639762"/>
           </a:xfrm>
         </p:spPr>
         <p:txBody>
@@ -1530,8 +1530,8 @@
         </p:nvSpPr>
         <p:spPr>
           <a:xfrm>
-            <a:off x="457200" y="2174875"/>
-            <a:ext cx="4040188" cy="3951288"/>
+            <a:off x="609584" y="2174875"/>
+            <a:ext cx="5386782" cy="3951288"/>
           </a:xfrm>
         </p:spPr>
         <p:txBody>
@@ -1615,8 +1615,8 @@
         </p:nvSpPr>
         <p:spPr>
           <a:xfrm>
-            <a:off x="4645025" y="1535113"/>
-            <a:ext cx="4041775" cy="639762"/>
+            <a:off x="6193211" y="1535113"/>
+            <a:ext cx="5388898" cy="639762"/>
           </a:xfrm>
         </p:spPr>
         <p:txBody>
@@ -1680,8 +1680,8 @@
         </p:nvSpPr>
         <p:spPr>
           <a:xfrm>
-            <a:off x="4645025" y="2174875"/>
-            <a:ext cx="4041775" cy="3951288"/>
+            <a:off x="6193211" y="2174875"/>
+            <a:ext cx="5388898" cy="3951288"/>
           </a:xfrm>
         </p:spPr>
         <p:txBody>
@@ -2073,8 +2073,8 @@
         </p:nvSpPr>
         <p:spPr>
           <a:xfrm>
-            <a:off x="457200" y="273050"/>
-            <a:ext cx="3008313" cy="1162050"/>
+            <a:off x="609584" y="273050"/>
+            <a:ext cx="4010983" cy="1162050"/>
           </a:xfrm>
         </p:spPr>
         <p:txBody>
@@ -2105,8 +2105,8 @@
         </p:nvSpPr>
         <p:spPr>
           <a:xfrm>
-            <a:off x="3575050" y="273050"/>
-            <a:ext cx="5111750" cy="5853113"/>
+            <a:off x="4766614" y="273050"/>
+            <a:ext cx="6815496" cy="5853113"/>
           </a:xfrm>
         </p:spPr>
         <p:txBody>
@@ -2190,8 +2190,8 @@
         </p:nvSpPr>
         <p:spPr>
           <a:xfrm>
-            <a:off x="457200" y="1435100"/>
-            <a:ext cx="3008313" cy="4691063"/>
+            <a:off x="609584" y="1435100"/>
+            <a:ext cx="4010983" cy="4691063"/>
           </a:xfrm>
         </p:spPr>
         <p:txBody>
@@ -2350,8 +2350,8 @@
         </p:nvSpPr>
         <p:spPr>
           <a:xfrm>
-            <a:off x="1792288" y="4800600"/>
-            <a:ext cx="5486400" cy="566738"/>
+            <a:off x="2389657" y="4800600"/>
+            <a:ext cx="7315016" cy="566738"/>
           </a:xfrm>
         </p:spPr>
         <p:txBody>
@@ -2382,8 +2382,8 @@
         </p:nvSpPr>
         <p:spPr>
           <a:xfrm>
-            <a:off x="1792288" y="612775"/>
-            <a:ext cx="5486400" cy="4114800"/>
+            <a:off x="2389657" y="612775"/>
+            <a:ext cx="7315016" cy="4114800"/>
           </a:xfrm>
         </p:spPr>
         <p:txBody>
@@ -2443,8 +2443,8 @@
         </p:nvSpPr>
         <p:spPr>
           <a:xfrm>
-            <a:off x="1792288" y="5367338"/>
-            <a:ext cx="5486400" cy="804862"/>
+            <a:off x="2389657" y="5367338"/>
+            <a:ext cx="7315016" cy="804862"/>
           </a:xfrm>
         </p:spPr>
         <p:txBody>
@@ -2608,8 +2608,8 @@
         </p:nvSpPr>
         <p:spPr>
           <a:xfrm>
-            <a:off x="457200" y="274638"/>
-            <a:ext cx="8229600" cy="1143000"/>
+            <a:off x="609584" y="274638"/>
+            <a:ext cx="10972525" cy="1143000"/>
           </a:xfrm>
           <a:prstGeom prst="rect">
             <a:avLst/>
@@ -2641,8 +2641,8 @@
         </p:nvSpPr>
         <p:spPr>
           <a:xfrm>
-            <a:off x="457200" y="1600200"/>
-            <a:ext cx="8229600" cy="4525963"/>
+            <a:off x="609584" y="1600200"/>
+            <a:ext cx="10972525" cy="4525963"/>
           </a:xfrm>
           <a:prstGeom prst="rect">
             <a:avLst/>
@@ -2703,8 +2703,8 @@
         </p:nvSpPr>
         <p:spPr>
           <a:xfrm>
-            <a:off x="457200" y="6356350"/>
-            <a:ext cx="2133600" cy="365125"/>
+            <a:off x="609584" y="6356350"/>
+            <a:ext cx="2844728" cy="365125"/>
           </a:xfrm>
           <a:prstGeom prst="rect">
             <a:avLst/>
@@ -2744,8 +2744,8 @@
         </p:nvSpPr>
         <p:spPr>
           <a:xfrm>
-            <a:off x="3124200" y="6356350"/>
-            <a:ext cx="2895600" cy="365125"/>
+            <a:off x="4165495" y="6356350"/>
+            <a:ext cx="3860703" cy="365125"/>
           </a:xfrm>
           <a:prstGeom prst="rect">
             <a:avLst/>
@@ -2781,8 +2781,8 @@
         </p:nvSpPr>
         <p:spPr>
           <a:xfrm>
-            <a:off x="6553200" y="6356350"/>
-            <a:ext cx="2133600" cy="365125"/>
+            <a:off x="8737381" y="6356350"/>
+            <a:ext cx="2844728" cy="365125"/>
           </a:xfrm>
           <a:prstGeom prst="rect">
             <a:avLst/>
@@ -3087,14 +3087,6 @@
 <file path=ppt/slides/slide1.xml><?xml version="1.0" encoding="utf-8"?>
 <p:sld xmlns:a="http://schemas.openxmlformats.org/drawingml/2006/main" xmlns:p="http://schemas.openxmlformats.org/presentationml/2006/main" xmlns:r="http://schemas.openxmlformats.org/officeDocument/2006/relationships">
   <p:cSld>
-    <p:bg>
-      <p:bgPr>
-        <a:solidFill>
-          <a:srgbClr val="FFFFFF"/>
-        </a:solidFill>
-        <a:effectLst/>
-      </p:bgPr>
-    </p:bg>
     <p:spTree>
       <p:nvGrpSpPr>
         <p:cNvPr id="1" name=""/>
@@ -3104,68 +3096,47 @@
       <p:grpSpPr/>
       <p:sp>
         <p:nvSpPr>
-          <p:cNvPr id="2" name="TextBox 1"/>
-          <p:cNvSpPr txBox="1"/>
-          <p:nvPr/>
-        </p:nvSpPr>
-        <p:spPr>
-          <a:xfrm>
-            <a:off x="1097280" y="2011680"/>
-            <a:ext cx="9966960" cy="2926080"/>
-          </a:xfrm>
-          <a:prstGeom prst="rect">
-            <a:avLst/>
-          </a:prstGeom>
-          <a:noFill/>
-        </p:spPr>
-        <p:txBody>
-          <a:bodyPr wrap="square">
-            <a:spAutoFit/>
-          </a:bodyPr>
-          <a:lstStyle/>
-          <a:p>
-            <a:pPr>
-              <a:defRPr sz="3200" b="1">
-                <a:solidFill>
-                  <a:srgbClr val="1E1E1E"/>
-                </a:solidFill>
-                <a:latin typeface="Arial"/>
-              </a:defRPr>
-            </a:pPr>
+          <p:cNvPr id="2" name="Title 1"/>
+          <p:cNvSpPr>
+            <a:spLocks noGrp="1"/>
+          </p:cNvSpPr>
+          <p:nvPr>
+            <p:ph type="ctrTitle"/>
+          </p:nvPr>
+        </p:nvSpPr>
+        <p:spPr/>
+        <p:txBody>
+          <a:bodyPr/>
+          <a:lstStyle/>
+          <a:p>
             <a:r>
               <a:t>HWNet: A Compact Temporal CNN for Motor Imagery</a:t>
             </a:r>
           </a:p>
-          <a:p>
-            <a:pPr>
-              <a:spcBef>
-                <a:spcPts val="1200"/>
-              </a:spcBef>
-              <a:defRPr sz="1800">
-                <a:solidFill>
-                  <a:srgbClr val="5A5A5A"/>
-                </a:solidFill>
-                <a:latin typeface="Arial"/>
-              </a:defRPr>
-            </a:pPr>
-            <a:r>
-              <a:t>Part 2: Model Architecture &amp; Part 3: Benchmark against MixNet</a:t>
-            </a:r>
-          </a:p>
-          <a:p>
-            <a:pPr>
-              <a:spcBef>
-                <a:spcPts val="2800"/>
-              </a:spcBef>
-              <a:defRPr sz="1400">
-                <a:solidFill>
-                  <a:srgbClr val="5A5A5A"/>
-                </a:solidFill>
-                <a:latin typeface="Arial"/>
-              </a:defRPr>
-            </a:pPr>
-            <a:r>
-              <a:t>Dataset: BCI Competition IV-2a (2-Class Left vs. Right Hand Motor Imagery)</a:t>
+        </p:txBody>
+      </p:sp>
+      <p:sp>
+        <p:nvSpPr>
+          <p:cNvPr id="3" name="Subtitle 2"/>
+          <p:cNvSpPr>
+            <a:spLocks noGrp="1"/>
+          </p:cNvSpPr>
+          <p:nvPr>
+            <p:ph type="subTitle" idx="1"/>
+          </p:nvPr>
+        </p:nvSpPr>
+        <p:spPr/>
+        <p:txBody>
+          <a:bodyPr/>
+          <a:lstStyle/>
+          <a:p>
+            <a:r>
+              <a:t>Parts 2–3: Model Architecture and Benchmark</a:t>
+            </a:r>
+          </a:p>
+          <a:p>
+            <a:r>
+              <a:t>BCI Competition IV-2a, 2-class (left vs. right hand)</a:t>
             </a:r>
           </a:p>
         </p:txBody>
@@ -3181,14 +3152,6 @@
 <file path=ppt/slides/slide2.xml><?xml version="1.0" encoding="utf-8"?>
 <p:sld xmlns:a="http://schemas.openxmlformats.org/drawingml/2006/main" xmlns:p="http://schemas.openxmlformats.org/presentationml/2006/main" xmlns:r="http://schemas.openxmlformats.org/officeDocument/2006/relationships">
   <p:cSld>
-    <p:bg>
-      <p:bgPr>
-        <a:solidFill>
-          <a:srgbClr val="FFFFFF"/>
-        </a:solidFill>
-        <a:effectLst/>
-      </p:bgPr>
-    </p:bg>
     <p:spTree>
       <p:nvGrpSpPr>
         <p:cNvPr id="1" name=""/>
@@ -3198,235 +3161,79 @@
       <p:grpSpPr/>
       <p:sp>
         <p:nvSpPr>
-          <p:cNvPr id="2" name="TextBox 1"/>
-          <p:cNvSpPr txBox="1"/>
-          <p:nvPr/>
-        </p:nvSpPr>
-        <p:spPr>
-          <a:xfrm>
-            <a:off x="731520" y="457200"/>
-            <a:ext cx="10698480" cy="1005840"/>
-          </a:xfrm>
-          <a:prstGeom prst="rect">
-            <a:avLst/>
-          </a:prstGeom>
-          <a:noFill/>
-        </p:spPr>
-        <p:txBody>
-          <a:bodyPr wrap="square" lIns="0" tIns="0" rIns="0" bIns="0">
-            <a:spAutoFit/>
-          </a:bodyPr>
-          <a:lstStyle/>
-          <a:p>
-            <a:pPr>
-              <a:defRPr sz="1100" b="1">
-                <a:solidFill>
-                  <a:srgbClr val="5A5A5A"/>
-                </a:solidFill>
-                <a:latin typeface="Arial"/>
-              </a:defRPr>
-            </a:pPr>
-            <a:r>
-              <a:t>PART 2 &amp; 3: MODEL ARCHITECTURE &amp; EVALUATION</a:t>
-            </a:r>
-          </a:p>
-          <a:p>
-            <a:pPr>
-              <a:spcBef>
-                <a:spcPts val="400"/>
-              </a:spcBef>
-              <a:defRPr sz="2400" b="1">
-                <a:solidFill>
-                  <a:srgbClr val="1E1E1E"/>
-                </a:solidFill>
-                <a:latin typeface="Arial"/>
-              </a:defRPr>
-            </a:pPr>
-            <a:r>
-              <a:t>Handoff from Preprocessing (Part 1 -&gt; Part 2)</a:t>
-            </a:r>
-          </a:p>
-        </p:txBody>
-      </p:sp>
-      <p:sp>
-        <p:nvSpPr>
-          <p:cNvPr id="3" name="TextBox 2"/>
-          <p:cNvSpPr txBox="1"/>
-          <p:nvPr/>
-        </p:nvSpPr>
-        <p:spPr>
-          <a:xfrm>
-            <a:off x="731520" y="1645920"/>
-            <a:ext cx="10698480" cy="4572000"/>
-          </a:xfrm>
-          <a:prstGeom prst="rect">
-            <a:avLst/>
-          </a:prstGeom>
-          <a:noFill/>
-        </p:spPr>
-        <p:txBody>
-          <a:bodyPr wrap="square">
-            <a:spAutoFit/>
-          </a:bodyPr>
-          <a:lstStyle/>
-          <a:p>
-            <a:pPr>
-              <a:spcBef>
-                <a:spcPts val="0"/>
-              </a:spcBef>
-              <a:defRPr sz="1500" b="1">
-                <a:solidFill>
-                  <a:srgbClr val="1E1E1E"/>
-                </a:solidFill>
-                <a:latin typeface="Arial"/>
-              </a:defRPr>
-            </a:pPr>
-            <a:r>
-              <a:t>Input representation provided by preprocessing:</a:t>
-            </a:r>
-          </a:p>
-          <a:p>
-            <a:pPr lvl="1">
-              <a:spcBef>
-                <a:spcPts val="400"/>
-              </a:spcBef>
-              <a:defRPr sz="1350" b="0">
-                <a:solidFill>
-                  <a:srgbClr val="5A5A5A"/>
-                </a:solidFill>
-                <a:latin typeface="Arial"/>
-              </a:defRPr>
-            </a:pPr>
-            <a:r>
-              <a:t>Trial shape: (36, 15) -- 36 spectral-spatial channels across 15 temporal windows</a:t>
-            </a:r>
-          </a:p>
-          <a:p>
-            <a:pPr>
-              <a:spcBef>
-                <a:spcPts val="1400"/>
-              </a:spcBef>
-              <a:defRPr sz="1500" b="1">
-                <a:solidFill>
-                  <a:srgbClr val="1E1E1E"/>
-                </a:solidFill>
-                <a:latin typeface="Arial"/>
-              </a:defRPr>
-            </a:pPr>
-            <a:r>
-              <a:t>Spatial &amp; spectral filtering already completed:</a:t>
-            </a:r>
-          </a:p>
-          <a:p>
-            <a:pPr lvl="1">
-              <a:spcBef>
-                <a:spcPts val="400"/>
-              </a:spcBef>
-              <a:defRPr sz="1350" b="0">
-                <a:solidFill>
-                  <a:srgbClr val="5A5A5A"/>
-                </a:solidFill>
-                <a:latin typeface="Arial"/>
-              </a:defRPr>
-            </a:pPr>
-            <a:r>
-              <a:t>9 sub-bands (4-40 Hz, Butterworth order 5) covering mu and beta sensorimotor rhythms</a:t>
-            </a:r>
-          </a:p>
-          <a:p>
-            <a:pPr lvl="1">
-              <a:spcBef>
-                <a:spcPts val="400"/>
-              </a:spcBef>
-              <a:defRPr sz="1350" b="0">
-                <a:solidFill>
-                  <a:srgbClr val="5A5A5A"/>
-                </a:solidFill>
-                <a:latin typeface="Arial"/>
-              </a:defRPr>
-            </a:pPr>
-            <a:r>
-              <a:t>4 Common Spatial Pattern (CSP) components per band = 36 spatial channels</a:t>
-            </a:r>
-          </a:p>
-          <a:p>
-            <a:pPr lvl="1">
-              <a:spcBef>
-                <a:spcPts val="400"/>
-              </a:spcBef>
-              <a:defRPr sz="1350" b="0">
-                <a:solidFill>
-                  <a:srgbClr val="5A5A5A"/>
-                </a:solidFill>
-                <a:latin typeface="Arial"/>
-              </a:defRPr>
-            </a:pPr>
-            <a:r>
-              <a:t>Sliding-window normalized log-variance (0.5 s window, 0.25 s hop) = 15 time steps</a:t>
-            </a:r>
-          </a:p>
-          <a:p>
-            <a:pPr>
-              <a:spcBef>
-                <a:spcPts val="1400"/>
-              </a:spcBef>
-              <a:defRPr sz="1500" b="1">
-                <a:solidFill>
-                  <a:srgbClr val="1E1E1E"/>
-                </a:solidFill>
-                <a:latin typeface="Arial"/>
-              </a:defRPr>
-            </a:pPr>
-            <a:r>
-              <a:t>Goal of HWNet architecture:</a:t>
-            </a:r>
-          </a:p>
-          <a:p>
-            <a:pPr lvl="1">
-              <a:spcBef>
-                <a:spcPts val="400"/>
-              </a:spcBef>
-              <a:defRPr sz="1350" b="0">
-                <a:solidFill>
-                  <a:srgbClr val="5A5A5A"/>
-                </a:solidFill>
-                <a:latin typeface="Arial"/>
-              </a:defRPr>
-            </a:pPr>
-            <a:r>
-              <a:t>Model the temporal evolution of ERD/ERS across the 15 time steps</a:t>
-            </a:r>
-          </a:p>
-          <a:p>
-            <a:pPr lvl="1">
-              <a:spcBef>
-                <a:spcPts val="400"/>
-              </a:spcBef>
-              <a:defRPr sz="1350" b="0">
-                <a:solidFill>
-                  <a:srgbClr val="5A5A5A"/>
-                </a:solidFill>
-                <a:latin typeface="Arial"/>
-              </a:defRPr>
-            </a:pPr>
-            <a:r>
-              <a:t>Prevent overfitting: BCI-IV-2a has only ~115 training trials per fold</a:t>
-            </a:r>
-          </a:p>
-          <a:p>
-            <a:pPr lvl="1">
-              <a:spcBef>
-                <a:spcPts val="400"/>
-              </a:spcBef>
-              <a:defRPr sz="1350" b="0">
-                <a:solidFill>
-                  <a:srgbClr val="5A5A5A"/>
-                </a:solidFill>
-                <a:latin typeface="Arial"/>
-              </a:defRPr>
-            </a:pPr>
-            <a:r>
-              <a:t>Avoid overparameterized architectures that memorize small-sample noise</a:t>
+          <p:cNvPr id="2" name="Title 1"/>
+          <p:cNvSpPr>
+            <a:spLocks noGrp="1"/>
+          </p:cNvSpPr>
+          <p:nvPr>
+            <p:ph type="title"/>
+          </p:nvPr>
+        </p:nvSpPr>
+        <p:spPr/>
+        <p:txBody>
+          <a:bodyPr/>
+          <a:lstStyle/>
+          <a:p>
+            <a:r>
+              <a:t>Input from Preprocessing (Part 1)</a:t>
+            </a:r>
+          </a:p>
+        </p:txBody>
+      </p:sp>
+      <p:sp>
+        <p:nvSpPr>
+          <p:cNvPr id="3" name="Content Placeholder 2"/>
+          <p:cNvSpPr>
+            <a:spLocks noGrp="1"/>
+          </p:cNvSpPr>
+          <p:nvPr>
+            <p:ph idx="1"/>
+          </p:nvPr>
+        </p:nvSpPr>
+        <p:spPr/>
+        <p:txBody>
+          <a:bodyPr/>
+          <a:lstStyle/>
+          <a:p>
+            <a:pPr/>
+            <a:r>
+              <a:rPr b="0" sz="2400"/>
+              <a:t>Each trial arrives as a 36 × 15 feature matrix</a:t>
+            </a:r>
+          </a:p>
+          <a:p>
+            <a:pPr lvl="1"/>
+            <a:r>
+              <a:rPr b="0" sz="2100"/>
+              <a:t>9 sub-bands (4–40 Hz) × 4 CSP components = 36 features</a:t>
+            </a:r>
+          </a:p>
+          <a:p>
+            <a:pPr lvl="1"/>
+            <a:r>
+              <a:rPr b="0" sz="2100"/>
+              <a:t>Log-variance in sliding windows (0.5 s, 0.25 s hop) = 15 time steps</a:t>
+            </a:r>
+          </a:p>
+          <a:p>
+            <a:pPr/>
+            <a:r>
+              <a:rPr b="0" sz="2400"/>
+              <a:t>Spatial and spectral filtering is already done</a:t>
+            </a:r>
+          </a:p>
+          <a:p>
+            <a:pPr/>
+            <a:r>
+              <a:rPr b="0" sz="2400"/>
+              <a:t>What is left for the model: the temporal evolution of ERD/ERS</a:t>
+            </a:r>
+          </a:p>
+          <a:p>
+            <a:pPr/>
+            <a:r>
+              <a:rPr b="0" sz="2400"/>
+              <a:t>Constraint: only ~115 training trials per fold, so the model must be small</a:t>
             </a:r>
           </a:p>
         </p:txBody>
@@ -3442,14 +3249,6 @@
 <file path=ppt/slides/slide3.xml><?xml version="1.0" encoding="utf-8"?>
 <p:sld xmlns:a="http://schemas.openxmlformats.org/drawingml/2006/main" xmlns:p="http://schemas.openxmlformats.org/presentationml/2006/main" xmlns:r="http://schemas.openxmlformats.org/officeDocument/2006/relationships">
   <p:cSld>
-    <p:bg>
-      <p:bgPr>
-        <a:solidFill>
-          <a:srgbClr val="FFFFFF"/>
-        </a:solidFill>
-        <a:effectLst/>
-      </p:bgPr>
-    </p:bg>
     <p:spTree>
       <p:nvGrpSpPr>
         <p:cNvPr id="1" name=""/>
@@ -3459,14 +3258,59 @@
       <p:grpSpPr/>
       <p:sp>
         <p:nvSpPr>
-          <p:cNvPr id="2" name="TextBox 1"/>
+          <p:cNvPr id="2" name="Title 1"/>
+          <p:cNvSpPr>
+            <a:spLocks noGrp="1"/>
+          </p:cNvSpPr>
+          <p:nvPr>
+            <p:ph type="title"/>
+          </p:nvPr>
+        </p:nvSpPr>
+        <p:spPr/>
+        <p:txBody>
+          <a:bodyPr/>
+          <a:lstStyle/>
+          <a:p>
+            <a:r>
+              <a:t>HWNet Architecture</a:t>
+            </a:r>
+          </a:p>
+        </p:txBody>
+      </p:sp>
+      <p:pic>
+        <p:nvPicPr>
+          <p:cNvPr id="3" name="Picture 2" descr="hwnet_architecture.png"/>
+          <p:cNvPicPr>
+            <a:picLocks noChangeAspect="1"/>
+          </p:cNvPicPr>
+          <p:nvPr/>
+        </p:nvPicPr>
+        <p:blipFill>
+          <a:blip r:embed="rId2"/>
+          <a:stretch>
+            <a:fillRect/>
+          </a:stretch>
+        </p:blipFill>
+        <p:spPr>
+          <a:xfrm>
+            <a:off x="658368" y="1508760"/>
+            <a:ext cx="10881360" cy="2989312"/>
+          </a:xfrm>
+          <a:prstGeom prst="rect">
+            <a:avLst/>
+          </a:prstGeom>
+        </p:spPr>
+      </p:pic>
+      <p:sp>
+        <p:nvSpPr>
+          <p:cNvPr id="4" name="TextBox 3"/>
           <p:cNvSpPr txBox="1"/>
           <p:nvPr/>
         </p:nvSpPr>
         <p:spPr>
           <a:xfrm>
-            <a:off x="731520" y="457200"/>
-            <a:ext cx="10698480" cy="1005840"/>
+            <a:off x="841248" y="4800600"/>
+            <a:ext cx="10515600" cy="1737360"/>
           </a:xfrm>
           <a:prstGeom prst="rect">
             <a:avLst/>
@@ -3474,560 +3318,44 @@
           <a:noFill/>
         </p:spPr>
         <p:txBody>
-          <a:bodyPr wrap="square" lIns="0" tIns="0" rIns="0" bIns="0">
-            <a:spAutoFit/>
-          </a:bodyPr>
-          <a:lstStyle/>
-          <a:p>
-            <a:pPr>
-              <a:defRPr sz="1100" b="1">
-                <a:solidFill>
-                  <a:srgbClr val="5A5A5A"/>
-                </a:solidFill>
-                <a:latin typeface="Arial"/>
-              </a:defRPr>
-            </a:pPr>
-            <a:r>
-              <a:t>PART 2 &amp; 3: MODEL ARCHITECTURE &amp; EVALUATION</a:t>
-            </a:r>
-          </a:p>
-          <a:p>
-            <a:pPr>
-              <a:spcBef>
-                <a:spcPts val="400"/>
-              </a:spcBef>
-              <a:defRPr sz="2400" b="1">
-                <a:solidFill>
-                  <a:srgbClr val="1E1E1E"/>
-                </a:solidFill>
-                <a:latin typeface="Arial"/>
-              </a:defRPr>
-            </a:pPr>
-            <a:r>
-              <a:t>HWNet Architecture: Compact 2-Block Temporal CNN</a:t>
-            </a:r>
-          </a:p>
-        </p:txBody>
-      </p:sp>
-      <p:sp>
-        <p:nvSpPr>
-          <p:cNvPr id="3" name="Rectangle 2"/>
-          <p:cNvSpPr/>
-          <p:nvPr/>
-        </p:nvSpPr>
-        <p:spPr>
-          <a:xfrm>
-            <a:off x="731520" y="1645920"/>
-            <a:ext cx="2286000" cy="1188720"/>
-          </a:xfrm>
-          <a:prstGeom prst="rect">
-            <a:avLst/>
-          </a:prstGeom>
-          <a:solidFill>
-            <a:srgbClr val="F5F5F5"/>
-          </a:solidFill>
-          <a:ln w="19050">
-            <a:solidFill>
-              <a:srgbClr val="B4B4B4"/>
-            </a:solidFill>
-          </a:ln>
-        </p:spPr>
-        <p:style>
-          <a:lnRef idx="1">
-            <a:schemeClr val="accent1"/>
-          </a:lnRef>
-          <a:fillRef idx="3">
-            <a:schemeClr val="accent1"/>
-          </a:fillRef>
-          <a:effectRef idx="2">
-            <a:schemeClr val="accent1"/>
-          </a:effectRef>
-          <a:fontRef idx="minor">
-            <a:schemeClr val="lt1"/>
-          </a:fontRef>
-        </p:style>
-        <p:txBody>
-          <a:bodyPr rtlCol="0" anchor="ctr" wrap="square" tIns="109728"/>
-          <a:lstStyle/>
-          <a:p>
-            <a:pPr algn="ctr">
-              <a:defRPr sz="1300" b="1">
-                <a:solidFill>
-                  <a:srgbClr val="1E1E1E"/>
-                </a:solidFill>
-                <a:latin typeface="Arial"/>
-              </a:defRPr>
-            </a:pPr>
-            <a:r>
-              <a:t>Input</a:t>
-            </a:r>
-          </a:p>
-          <a:p>
-            <a:pPr algn="ctr">
-              <a:spcBef>
-                <a:spcPts val="400"/>
-              </a:spcBef>
-              <a:defRPr sz="1050">
-                <a:solidFill>
-                  <a:srgbClr val="5A5A5A"/>
-                </a:solidFill>
-                <a:latin typeface="Arial"/>
-              </a:defRPr>
-            </a:pPr>
-            <a:r>
-              <a:t>(1, 15, 36)</a:t>
-            </a:r>
-            <a:br/>
-            <a:r>
-              <a:t>Time=15, Ch=36</a:t>
-            </a:r>
-          </a:p>
-        </p:txBody>
-      </p:sp>
-      <p:sp>
-        <p:nvSpPr>
-          <p:cNvPr id="4" name="TextBox 3"/>
-          <p:cNvSpPr txBox="1"/>
-          <p:nvPr/>
-        </p:nvSpPr>
-        <p:spPr>
-          <a:xfrm>
-            <a:off x="3090672" y="1965960"/>
-            <a:ext cx="228600" cy="457200"/>
-          </a:xfrm>
-          <a:prstGeom prst="rect">
-            <a:avLst/>
-          </a:prstGeom>
-          <a:noFill/>
-        </p:spPr>
-        <p:txBody>
-          <a:bodyPr wrap="none">
-            <a:spAutoFit/>
-          </a:bodyPr>
-          <a:lstStyle/>
-          <a:p>
-            <a:pPr>
-              <a:defRPr sz="1600" b="1">
-                <a:solidFill>
-                  <a:srgbClr val="5A5A5A"/>
-                </a:solidFill>
-                <a:latin typeface="Arial"/>
-              </a:defRPr>
-            </a:pPr>
-            <a:r>
-              <a:t>-&gt;</a:t>
-            </a:r>
-          </a:p>
-        </p:txBody>
-      </p:sp>
-      <p:sp>
-        <p:nvSpPr>
-          <p:cNvPr id="5" name="Rectangle 4"/>
-          <p:cNvSpPr/>
-          <p:nvPr/>
-        </p:nvSpPr>
-        <p:spPr>
-          <a:xfrm>
-            <a:off x="3383280" y="1645920"/>
-            <a:ext cx="2286000" cy="1188720"/>
-          </a:xfrm>
-          <a:prstGeom prst="rect">
-            <a:avLst/>
-          </a:prstGeom>
-          <a:solidFill>
-            <a:srgbClr val="F5F5F5"/>
-          </a:solidFill>
-          <a:ln w="19050">
-            <a:solidFill>
-              <a:srgbClr val="B4B4B4"/>
-            </a:solidFill>
-          </a:ln>
-        </p:spPr>
-        <p:style>
-          <a:lnRef idx="1">
-            <a:schemeClr val="accent1"/>
-          </a:lnRef>
-          <a:fillRef idx="3">
-            <a:schemeClr val="accent1"/>
-          </a:fillRef>
-          <a:effectRef idx="2">
-            <a:schemeClr val="accent1"/>
-          </a:effectRef>
-          <a:fontRef idx="minor">
-            <a:schemeClr val="lt1"/>
-          </a:fontRef>
-        </p:style>
-        <p:txBody>
-          <a:bodyPr rtlCol="0" anchor="ctr" wrap="square" tIns="109728"/>
-          <a:lstStyle/>
-          <a:p>
-            <a:pPr algn="ctr">
-              <a:defRPr sz="1300" b="1">
-                <a:solidFill>
-                  <a:srgbClr val="1E1E1E"/>
-                </a:solidFill>
-                <a:latin typeface="Arial"/>
-              </a:defRPr>
-            </a:pPr>
-            <a:r>
-              <a:t>Block 1</a:t>
-            </a:r>
-          </a:p>
-          <a:p>
-            <a:pPr algn="ctr">
-              <a:spcBef>
-                <a:spcPts val="400"/>
-              </a:spcBef>
-              <a:defRPr sz="1050">
-                <a:solidFill>
-                  <a:srgbClr val="5A5A5A"/>
-                </a:solidFill>
-                <a:latin typeface="Arial"/>
-              </a:defRPr>
-            </a:pPr>
-            <a:r>
-              <a:t>Conv2D (1x3, 32 filters)</a:t>
-            </a:r>
-            <a:br/>
-            <a:r>
-              <a:t>BatchNorm + ELU</a:t>
-            </a:r>
-            <a:br/>
-            <a:r>
-              <a:t>Dropout (0.5)</a:t>
-            </a:r>
-          </a:p>
-        </p:txBody>
-      </p:sp>
-      <p:sp>
-        <p:nvSpPr>
-          <p:cNvPr id="6" name="TextBox 5"/>
-          <p:cNvSpPr txBox="1"/>
-          <p:nvPr/>
-        </p:nvSpPr>
-        <p:spPr>
-          <a:xfrm>
-            <a:off x="5742432" y="1965960"/>
-            <a:ext cx="228600" cy="457200"/>
-          </a:xfrm>
-          <a:prstGeom prst="rect">
-            <a:avLst/>
-          </a:prstGeom>
-          <a:noFill/>
-        </p:spPr>
-        <p:txBody>
-          <a:bodyPr wrap="none">
-            <a:spAutoFit/>
-          </a:bodyPr>
-          <a:lstStyle/>
-          <a:p>
-            <a:pPr>
-              <a:defRPr sz="1600" b="1">
-                <a:solidFill>
-                  <a:srgbClr val="5A5A5A"/>
-                </a:solidFill>
-                <a:latin typeface="Arial"/>
-              </a:defRPr>
-            </a:pPr>
-            <a:r>
-              <a:t>-&gt;</a:t>
-            </a:r>
-          </a:p>
-        </p:txBody>
-      </p:sp>
-      <p:sp>
-        <p:nvSpPr>
-          <p:cNvPr id="7" name="Rectangle 6"/>
-          <p:cNvSpPr/>
-          <p:nvPr/>
-        </p:nvSpPr>
-        <p:spPr>
-          <a:xfrm>
-            <a:off x="6035040" y="1645920"/>
-            <a:ext cx="2286000" cy="1188720"/>
-          </a:xfrm>
-          <a:prstGeom prst="rect">
-            <a:avLst/>
-          </a:prstGeom>
-          <a:solidFill>
-            <a:srgbClr val="F5F5F5"/>
-          </a:solidFill>
-          <a:ln w="19050">
-            <a:solidFill>
-              <a:srgbClr val="B4B4B4"/>
-            </a:solidFill>
-          </a:ln>
-        </p:spPr>
-        <p:style>
-          <a:lnRef idx="1">
-            <a:schemeClr val="accent1"/>
-          </a:lnRef>
-          <a:fillRef idx="3">
-            <a:schemeClr val="accent1"/>
-          </a:fillRef>
-          <a:effectRef idx="2">
-            <a:schemeClr val="accent1"/>
-          </a:effectRef>
-          <a:fontRef idx="minor">
-            <a:schemeClr val="lt1"/>
-          </a:fontRef>
-        </p:style>
-        <p:txBody>
-          <a:bodyPr rtlCol="0" anchor="ctr" wrap="square" tIns="109728"/>
-          <a:lstStyle/>
-          <a:p>
-            <a:pPr algn="ctr">
-              <a:defRPr sz="1300" b="1">
-                <a:solidFill>
-                  <a:srgbClr val="1E1E1E"/>
-                </a:solidFill>
-                <a:latin typeface="Arial"/>
-              </a:defRPr>
-            </a:pPr>
-            <a:r>
-              <a:t>Block 2</a:t>
-            </a:r>
-          </a:p>
-          <a:p>
-            <a:pPr algn="ctr">
-              <a:spcBef>
-                <a:spcPts val="400"/>
-              </a:spcBef>
-              <a:defRPr sz="1050">
-                <a:solidFill>
-                  <a:srgbClr val="5A5A5A"/>
-                </a:solidFill>
-                <a:latin typeface="Arial"/>
-              </a:defRPr>
-            </a:pPr>
-            <a:r>
-              <a:t>Conv2D (1x3, 16 filters)</a:t>
-            </a:r>
-            <a:br/>
-            <a:r>
-              <a:t>BatchNorm + ELU</a:t>
-            </a:r>
-            <a:br/>
-            <a:r>
-              <a:t>AvgPool (1x2) + Drop (0.5)</a:t>
-            </a:r>
-          </a:p>
-        </p:txBody>
-      </p:sp>
-      <p:sp>
-        <p:nvSpPr>
-          <p:cNvPr id="8" name="TextBox 7"/>
-          <p:cNvSpPr txBox="1"/>
-          <p:nvPr/>
-        </p:nvSpPr>
-        <p:spPr>
-          <a:xfrm>
-            <a:off x="8394192" y="1965960"/>
-            <a:ext cx="228600" cy="457200"/>
-          </a:xfrm>
-          <a:prstGeom prst="rect">
-            <a:avLst/>
-          </a:prstGeom>
-          <a:noFill/>
-        </p:spPr>
-        <p:txBody>
-          <a:bodyPr wrap="none">
-            <a:spAutoFit/>
-          </a:bodyPr>
-          <a:lstStyle/>
-          <a:p>
-            <a:pPr>
-              <a:defRPr sz="1600" b="1">
-                <a:solidFill>
-                  <a:srgbClr val="5A5A5A"/>
-                </a:solidFill>
-                <a:latin typeface="Arial"/>
-              </a:defRPr>
-            </a:pPr>
-            <a:r>
-              <a:t>-&gt;</a:t>
-            </a:r>
-          </a:p>
-        </p:txBody>
-      </p:sp>
-      <p:sp>
-        <p:nvSpPr>
-          <p:cNvPr id="9" name="Rectangle 8"/>
-          <p:cNvSpPr/>
-          <p:nvPr/>
-        </p:nvSpPr>
-        <p:spPr>
-          <a:xfrm>
-            <a:off x="8686800" y="1645920"/>
-            <a:ext cx="2286000" cy="1188720"/>
-          </a:xfrm>
-          <a:prstGeom prst="rect">
-            <a:avLst/>
-          </a:prstGeom>
-          <a:solidFill>
-            <a:srgbClr val="F5F5F5"/>
-          </a:solidFill>
-          <a:ln w="19050">
-            <a:solidFill>
-              <a:srgbClr val="B4B4B4"/>
-            </a:solidFill>
-          </a:ln>
-        </p:spPr>
-        <p:style>
-          <a:lnRef idx="1">
-            <a:schemeClr val="accent1"/>
-          </a:lnRef>
-          <a:fillRef idx="3">
-            <a:schemeClr val="accent1"/>
-          </a:fillRef>
-          <a:effectRef idx="2">
-            <a:schemeClr val="accent1"/>
-          </a:effectRef>
-          <a:fontRef idx="minor">
-            <a:schemeClr val="lt1"/>
-          </a:fontRef>
-        </p:style>
-        <p:txBody>
-          <a:bodyPr rtlCol="0" anchor="ctr" wrap="square" tIns="109728"/>
-          <a:lstStyle/>
-          <a:p>
-            <a:pPr algn="ctr">
-              <a:defRPr sz="1300" b="1">
-                <a:solidFill>
-                  <a:srgbClr val="1E1E1E"/>
-                </a:solidFill>
-                <a:latin typeface="Arial"/>
-              </a:defRPr>
-            </a:pPr>
-            <a:r>
-              <a:t>Classifier Head</a:t>
-            </a:r>
-          </a:p>
-          <a:p>
-            <a:pPr algn="ctr">
-              <a:spcBef>
-                <a:spcPts val="400"/>
-              </a:spcBef>
-              <a:defRPr sz="1050">
-                <a:solidFill>
-                  <a:srgbClr val="5A5A5A"/>
-                </a:solidFill>
-                <a:latin typeface="Arial"/>
-              </a:defRPr>
-            </a:pPr>
-            <a:r>
-              <a:t>Flatten (112 features)</a:t>
-            </a:r>
-            <a:br/>
-            <a:r>
-              <a:t>Dense (2 units, max_norm)</a:t>
-            </a:r>
-            <a:br/>
-            <a:r>
-              <a:t>Softmax Activation</a:t>
-            </a:r>
-          </a:p>
-        </p:txBody>
-      </p:sp>
-      <p:sp>
-        <p:nvSpPr>
-          <p:cNvPr id="10" name="TextBox 9"/>
-          <p:cNvSpPr txBox="1"/>
-          <p:nvPr/>
-        </p:nvSpPr>
-        <p:spPr>
-          <a:xfrm>
-            <a:off x="731520" y="3108960"/>
-            <a:ext cx="10698480" cy="3291840"/>
-          </a:xfrm>
-          <a:prstGeom prst="rect">
-            <a:avLst/>
-          </a:prstGeom>
-          <a:noFill/>
-        </p:spPr>
-        <p:txBody>
           <a:bodyPr wrap="square">
             <a:spAutoFit/>
           </a:bodyPr>
           <a:lstStyle/>
           <a:p>
-            <a:pPr>
-              <a:spcBef>
-                <a:spcPts val="0"/>
-              </a:spcBef>
-              <a:defRPr sz="1500" b="1">
-                <a:solidFill>
-                  <a:srgbClr val="1E1E1E"/>
-                </a:solidFill>
-                <a:latin typeface="Arial"/>
-              </a:defRPr>
-            </a:pPr>
-            <a:r>
-              <a:t>Key Architectural Features:</a:t>
-            </a:r>
-          </a:p>
-          <a:p>
-            <a:pPr lvl="1">
+            <a:pPr marL="274320" indent="-274320" lvl="0">
               <a:spcBef>
                 <a:spcPts val="600"/>
               </a:spcBef>
-              <a:defRPr sz="1350" b="0">
-                <a:solidFill>
-                  <a:srgbClr val="5A5A5A"/>
-                </a:solidFill>
-                <a:latin typeface="Arial"/>
-              </a:defRPr>
+              <a:buChar char="•"/>
             </a:pPr>
             <a:r>
-              <a:t>Matched Temporal Receptive Field: 1x3 kernel spans 3 time windows (~1.0 second), targeting ERD onset.</a:t>
-            </a:r>
-          </a:p>
-          <a:p>
-            <a:pPr lvl="1">
+              <a:rPr b="0" sz="1800"/>
+              <a:t>Two temporal conv blocks: 1×3 kernels slide over time only (≈1.0 s per kernel)</a:t>
+            </a:r>
+          </a:p>
+          <a:p>
+            <a:pPr marL="274320" indent="-274320" lvl="0">
               <a:spcBef>
                 <a:spcPts val="600"/>
               </a:spcBef>
-              <a:defRPr sz="1350" b="0">
-                <a:solidFill>
-                  <a:srgbClr val="5A5A5A"/>
-                </a:solidFill>
-                <a:latin typeface="Arial"/>
-              </a:defRPr>
+              <a:buChar char="•"/>
             </a:pPr>
             <a:r>
-              <a:t>Aggressive Regularization: Dual 50% Dropout + Batch Normalization + max_norm(0.5) kernel constraints.</a:t>
-            </a:r>
-          </a:p>
-          <a:p>
-            <a:pPr lvl="1">
+              <a:rPr b="0" sz="1800"/>
+              <a:t>Regularisation: dropout 0.5 (×2), batch norm, max-norm 0.5</a:t>
+            </a:r>
+          </a:p>
+          <a:p>
+            <a:pPr marL="274320" indent="-274320" lvl="0">
               <a:spcBef>
                 <a:spcPts val="600"/>
               </a:spcBef>
-              <a:defRPr sz="1350" b="0">
-                <a:solidFill>
-                  <a:srgbClr val="5A5A5A"/>
-                </a:solidFill>
-                <a:latin typeface="Arial"/>
-              </a:defRPr>
+              <a:buChar char="•"/>
             </a:pPr>
             <a:r>
-              <a:t>Extreme Parameter Efficiency: Only 5,362 trainable parameters (vs. 44,777 in MixNet).</a:t>
-            </a:r>
-          </a:p>
-          <a:p>
-            <a:pPr lvl="1">
-              <a:spcBef>
-                <a:spcPts val="600"/>
-              </a:spcBef>
-              <a:defRPr sz="1350" b="0">
-                <a:solidFill>
-                  <a:srgbClr val="5A5A5A"/>
-                </a:solidFill>
-                <a:latin typeface="Arial"/>
-              </a:defRPr>
-            </a:pPr>
-            <a:r>
-              <a:t>Single-Task Training: Simple cross-entropy objective without auxiliary reconstruction or triplet loss tuning.</a:t>
+              <a:rPr b="0" sz="1800"/>
+              <a:t>5,362 trainable parameters, trained with plain cross-entropy</a:t>
             </a:r>
           </a:p>
         </p:txBody>
@@ -4043,14 +3371,6 @@
 <file path=ppt/slides/slide4.xml><?xml version="1.0" encoding="utf-8"?>
 <p:sld xmlns:a="http://schemas.openxmlformats.org/drawingml/2006/main" xmlns:p="http://schemas.openxmlformats.org/presentationml/2006/main" xmlns:r="http://schemas.openxmlformats.org/officeDocument/2006/relationships">
   <p:cSld>
-    <p:bg>
-      <p:bgPr>
-        <a:solidFill>
-          <a:srgbClr val="FFFFFF"/>
-        </a:solidFill>
-        <a:effectLst/>
-      </p:bgPr>
-    </p:bg>
     <p:spTree>
       <p:nvGrpSpPr>
         <p:cNvPr id="1" name=""/>
@@ -4060,52 +3380,21 @@
       <p:grpSpPr/>
       <p:sp>
         <p:nvSpPr>
-          <p:cNvPr id="2" name="TextBox 1"/>
-          <p:cNvSpPr txBox="1"/>
-          <p:nvPr/>
-        </p:nvSpPr>
-        <p:spPr>
-          <a:xfrm>
-            <a:off x="731520" y="457200"/>
-            <a:ext cx="10698480" cy="1005840"/>
-          </a:xfrm>
-          <a:prstGeom prst="rect">
-            <a:avLst/>
-          </a:prstGeom>
-          <a:noFill/>
-        </p:spPr>
-        <p:txBody>
-          <a:bodyPr wrap="square" lIns="0" tIns="0" rIns="0" bIns="0">
-            <a:spAutoFit/>
-          </a:bodyPr>
-          <a:lstStyle/>
-          <a:p>
-            <a:pPr>
-              <a:defRPr sz="1100" b="1">
-                <a:solidFill>
-                  <a:srgbClr val="5A5A5A"/>
-                </a:solidFill>
-                <a:latin typeface="Arial"/>
-              </a:defRPr>
-            </a:pPr>
-            <a:r>
-              <a:t>PART 2 &amp; 3: MODEL ARCHITECTURE &amp; EVALUATION</a:t>
-            </a:r>
-          </a:p>
-          <a:p>
-            <a:pPr>
-              <a:spcBef>
-                <a:spcPts val="400"/>
-              </a:spcBef>
-              <a:defRPr sz="2400" b="1">
-                <a:solidFill>
-                  <a:srgbClr val="1E1E1E"/>
-                </a:solidFill>
-                <a:latin typeface="Arial"/>
-              </a:defRPr>
-            </a:pPr>
-            <a:r>
-              <a:t>Model Comparison: HWNet vs. MixNet</a:t>
+          <p:cNvPr id="2" name="Title 1"/>
+          <p:cNvSpPr>
+            <a:spLocks noGrp="1"/>
+          </p:cNvSpPr>
+          <p:nvPr>
+            <p:ph type="title"/>
+          </p:nvPr>
+        </p:nvSpPr>
+        <p:spPr/>
+        <p:txBody>
+          <a:bodyPr/>
+          <a:lstStyle/>
+          <a:p>
+            <a:r>
+              <a:t>HWNet vs. MixNet</a:t>
             </a:r>
           </a:p>
         </p:txBody>
@@ -4119,8 +3408,8 @@
           <p:nvPr/>
         </p:nvGraphicFramePr>
         <p:xfrm>
-          <a:off x="731520" y="1645920"/>
-          <a:ext cx="10698480" cy="2377440"/>
+          <a:off x="841248" y="1554480"/>
+          <a:ext cx="10515599" cy="2194560"/>
         </p:xfrm>
         <a:graphic>
           <a:graphicData uri="http://schemas.openxmlformats.org/drawingml/2006/table">
@@ -4129,110 +3418,27 @@
                 <a:tableStyleId>{5C22544A-7EE6-4342-B048-85BDC9FD1C3A}</a:tableStyleId>
               </a:tblPr>
               <a:tblGrid>
-                <a:gridCol w="2286000"/>
-                <a:gridCol w="2926080"/>
-                <a:gridCol w="2560320"/>
-                <a:gridCol w="2926080"/>
+                <a:gridCol w="3108960"/>
+                <a:gridCol w="3657600"/>
+                <a:gridCol w="3749039"/>
               </a:tblGrid>
-              <a:tr h="396240">
+              <a:tr h="365760">
                 <a:tc>
                   <a:txBody>
                     <a:bodyPr/>
                     <a:lstStyle/>
-                    <a:p>
-                      <a:pPr>
-                        <a:defRPr b="1" sz="1200">
-                          <a:latin typeface="Arial"/>
-                        </a:defRPr>
-                      </a:pPr>
-                      <a:r>
-                        <a:t>Dimension</a:t>
-                      </a:r>
-                    </a:p>
+                    <a:p/>
                   </a:txBody>
-                  <a:tcPr>
-                    <a:solidFill>
-                      <a:srgbClr val="F5F5F5"/>
-                    </a:solidFill>
-                  </a:tcPr>
+                  <a:tcPr/>
                 </a:tc>
                 <a:tc>
                   <a:txBody>
                     <a:bodyPr/>
                     <a:lstStyle/>
                     <a:p>
-                      <a:pPr>
-                        <a:defRPr b="1" sz="1200">
-                          <a:latin typeface="Arial"/>
-                        </a:defRPr>
-                      </a:pPr>
                       <a:r>
-                        <a:t>MixNet (Baseline)</a:t>
-                      </a:r>
-                    </a:p>
-                  </a:txBody>
-                  <a:tcPr>
-                    <a:solidFill>
-                      <a:srgbClr val="F5F5F5"/>
-                    </a:solidFill>
-                  </a:tcPr>
-                </a:tc>
-                <a:tc>
-                  <a:txBody>
-                    <a:bodyPr/>
-                    <a:lstStyle/>
-                    <a:p>
-                      <a:pPr>
-                        <a:defRPr b="1" sz="1200">
-                          <a:latin typeface="Arial"/>
-                        </a:defRPr>
-                      </a:pPr>
-                      <a:r>
-                        <a:t>HWNet (Ours)</a:t>
-                      </a:r>
-                    </a:p>
-                  </a:txBody>
-                  <a:tcPr>
-                    <a:solidFill>
-                      <a:srgbClr val="F5F5F5"/>
-                    </a:solidFill>
-                  </a:tcPr>
-                </a:tc>
-                <a:tc>
-                  <a:txBody>
-                    <a:bodyPr/>
-                    <a:lstStyle/>
-                    <a:p>
-                      <a:pPr>
-                        <a:defRPr b="1" sz="1200">
-                          <a:latin typeface="Arial"/>
-                        </a:defRPr>
-                      </a:pPr>
-                      <a:r>
-                        <a:t>Design Rationale</a:t>
-                      </a:r>
-                    </a:p>
-                  </a:txBody>
-                  <a:tcPr>
-                    <a:solidFill>
-                      <a:srgbClr val="F5F5F5"/>
-                    </a:solidFill>
-                  </a:tcPr>
-                </a:tc>
-              </a:tr>
-              <a:tr h="396240">
-                <a:tc>
-                  <a:txBody>
-                    <a:bodyPr/>
-                    <a:lstStyle/>
-                    <a:p>
-                      <a:pPr>
-                        <a:defRPr sz="1150">
-                          <a:latin typeface="Arial"/>
-                        </a:defRPr>
-                      </a:pPr>
-                      <a:r>
-                        <a:t>Input Domain</a:t>
+                        <a:rPr sz="1600"/>
+                        <a:t>MixNet (baseline)</a:t>
                       </a:r>
                     </a:p>
                   </a:txBody>
@@ -4243,13 +3449,24 @@
                     <a:bodyPr/>
                     <a:lstStyle/>
                     <a:p>
-                      <a:pPr>
-                        <a:defRPr sz="1150">
-                          <a:latin typeface="Arial"/>
-                        </a:defRPr>
-                      </a:pPr>
                       <a:r>
-                        <a:t>Raw continuous EEG: (1, 400, 18)</a:t>
+                        <a:rPr sz="1600"/>
+                        <a:t>HWNet (ours)</a:t>
+                      </a:r>
+                    </a:p>
+                  </a:txBody>
+                  <a:tcPr/>
+                </a:tc>
+              </a:tr>
+              <a:tr h="365760">
+                <a:tc>
+                  <a:txBody>
+                    <a:bodyPr/>
+                    <a:lstStyle/>
+                    <a:p>
+                      <a:r>
+                        <a:rPr sz="1600"/>
+                        <a:t>Input</a:t>
                       </a:r>
                     </a:p>
                   </a:txBody>
@@ -4260,13 +3477,9 @@
                     <a:bodyPr/>
                     <a:lstStyle/>
                     <a:p>
-                      <a:pPr>
-                        <a:defRPr sz="1150">
-                          <a:latin typeface="Arial"/>
-                        </a:defRPr>
-                      </a:pPr>
                       <a:r>
-                        <a:t>Windowed power: (1, 15, 36)</a:t>
+                        <a:rPr sz="1600"/>
+                        <a:t>Raw EEG, 1 × 400 × 18</a:t>
                       </a:r>
                     </a:p>
                   </a:txBody>
@@ -4277,32 +3490,24 @@
                     <a:bodyPr/>
                     <a:lstStyle/>
                     <a:p>
-                      <a:pPr>
-                        <a:defRPr sz="1150">
-                          <a:latin typeface="Arial"/>
-                        </a:defRPr>
-                      </a:pPr>
                       <a:r>
-                        <a:t>Higher SNR, compact representation</a:t>
+                        <a:rPr sz="1600"/>
+                        <a:t>Windowed FBCSP power, 1 × 15 × 36</a:t>
                       </a:r>
                     </a:p>
                   </a:txBody>
                   <a:tcPr/>
                 </a:tc>
               </a:tr>
-              <a:tr h="396240">
+              <a:tr h="365760">
                 <a:tc>
                   <a:txBody>
                     <a:bodyPr/>
                     <a:lstStyle/>
                     <a:p>
-                      <a:pPr>
-                        <a:defRPr sz="1150">
-                          <a:latin typeface="Arial"/>
-                        </a:defRPr>
-                      </a:pPr>
                       <a:r>
-                        <a:t>Trainable Parameters</a:t>
+                        <a:rPr sz="1600"/>
+                        <a:t>Trainable parameters</a:t>
                       </a:r>
                     </a:p>
                   </a:txBody>
@@ -4313,13 +3518,9 @@
                     <a:bodyPr/>
                     <a:lstStyle/>
                     <a:p>
-                      <a:pPr>
-                        <a:defRPr sz="1150">
-                          <a:latin typeface="Arial"/>
-                        </a:defRPr>
-                      </a:pPr>
                       <a:r>
-                        <a:t>44,777 parameters</a:t>
+                        <a:rPr sz="1600"/>
+                        <a:t>44,777</a:t>
                       </a:r>
                     </a:p>
                   </a:txBody>
@@ -4330,13 +3531,24 @@
                     <a:bodyPr/>
                     <a:lstStyle/>
                     <a:p>
-                      <a:pPr>
-                        <a:defRPr sz="1150" b="1">
-                          <a:latin typeface="Arial"/>
-                        </a:defRPr>
-                      </a:pPr>
                       <a:r>
-                        <a:t>5,362 parameters (~8x smaller)</a:t>
+                        <a:rPr sz="1600"/>
+                        <a:t>5,362 (~8× fewer)</a:t>
+                      </a:r>
+                    </a:p>
+                  </a:txBody>
+                  <a:tcPr/>
+                </a:tc>
+              </a:tr>
+              <a:tr h="365760">
+                <a:tc>
+                  <a:txBody>
+                    <a:bodyPr/>
+                    <a:lstStyle/>
+                    <a:p>
+                      <a:r>
+                        <a:rPr sz="1600"/>
+                        <a:t>Loss</a:t>
                       </a:r>
                     </a:p>
                   </a:txBody>
@@ -4347,32 +3559,9 @@
                     <a:bodyPr/>
                     <a:lstStyle/>
                     <a:p>
-                      <a:pPr>
-                        <a:defRPr sz="1150">
-                          <a:latin typeface="Arial"/>
-                        </a:defRPr>
-                      </a:pPr>
                       <a:r>
-                        <a:t>Drastically reduces risk of overfitting</a:t>
-                      </a:r>
-                    </a:p>
-                  </a:txBody>
-                  <a:tcPr/>
-                </a:tc>
-              </a:tr>
-              <a:tr h="396240">
-                <a:tc>
-                  <a:txBody>
-                    <a:bodyPr/>
-                    <a:lstStyle/>
-                    <a:p>
-                      <a:pPr>
-                        <a:defRPr sz="1150">
-                          <a:latin typeface="Arial"/>
-                        </a:defRPr>
-                      </a:pPr>
-                      <a:r>
-                        <a:t>Objective / Loss</a:t>
+                        <a:rPr sz="1600"/>
+                        <a:t>MSE + triplet + cross-entropy</a:t>
                       </a:r>
                     </a:p>
                   </a:txBody>
@@ -4383,13 +3572,24 @@
                     <a:bodyPr/>
                     <a:lstStyle/>
                     <a:p>
-                      <a:pPr>
-                        <a:defRPr sz="1150">
-                          <a:latin typeface="Arial"/>
-                        </a:defRPr>
-                      </a:pPr>
                       <a:r>
-                        <a:t>MSE + Triplet + Cross-Entropy</a:t>
+                        <a:rPr sz="1600"/>
+                        <a:t>Cross-entropy only</a:t>
+                      </a:r>
+                    </a:p>
+                  </a:txBody>
+                  <a:tcPr/>
+                </a:tc>
+              </a:tr>
+              <a:tr h="365760">
+                <a:tc>
+                  <a:txBody>
+                    <a:bodyPr/>
+                    <a:lstStyle/>
+                    <a:p>
+                      <a:r>
+                        <a:rPr sz="1600"/>
+                        <a:t>Temporal kernels</a:t>
                       </a:r>
                     </a:p>
                   </a:txBody>
@@ -4400,13 +3600,9 @@
                     <a:bodyPr/>
                     <a:lstStyle/>
                     <a:p>
-                      <a:pPr>
-                        <a:defRPr sz="1150">
-                          <a:latin typeface="Arial"/>
-                        </a:defRPr>
-                      </a:pPr>
                       <a:r>
-                        <a:t>Cross-Entropy (Single-task)</a:t>
+                        <a:rPr sz="1600"/>
+                        <a:t>64 and 32 samples</a:t>
                       </a:r>
                     </a:p>
                   </a:txBody>
@@ -4417,32 +3613,24 @@
                     <a:bodyPr/>
                     <a:lstStyle/>
                     <a:p>
-                      <a:pPr>
-                        <a:defRPr sz="1150">
-                          <a:latin typeface="Arial"/>
-                        </a:defRPr>
-                      </a:pPr>
                       <a:r>
-                        <a:t>No triplet margin / weight tuning</a:t>
+                        <a:rPr sz="1600"/>
+                        <a:t>3 windows (≈1.0 s)</a:t>
                       </a:r>
                     </a:p>
                   </a:txBody>
                   <a:tcPr/>
                 </a:tc>
               </a:tr>
-              <a:tr h="396240">
+              <a:tr h="365760">
                 <a:tc>
                   <a:txBody>
                     <a:bodyPr/>
                     <a:lstStyle/>
                     <a:p>
-                      <a:pPr>
-                        <a:defRPr sz="1150">
-                          <a:latin typeface="Arial"/>
-                        </a:defRPr>
-                      </a:pPr>
                       <a:r>
-                        <a:t>Temporal Kernels</a:t>
+                        <a:rPr sz="1600"/>
+                        <a:t>Training time, 9 subjects (GPU)</a:t>
                       </a:r>
                     </a:p>
                   </a:txBody>
@@ -4453,13 +3641,9 @@
                     <a:bodyPr/>
                     <a:lstStyle/>
                     <a:p>
-                      <a:pPr>
-                        <a:defRPr sz="1150">
-                          <a:latin typeface="Arial"/>
-                        </a:defRPr>
-                      </a:pPr>
                       <a:r>
-                        <a:t>Length 64 and 32 samples</a:t>
+                        <a:rPr sz="1600"/>
+                        <a:t>~18 min</a:t>
                       </a:r>
                     </a:p>
                   </a:txBody>
@@ -4470,100 +3654,9 @@
                     <a:bodyPr/>
                     <a:lstStyle/>
                     <a:p>
-                      <a:pPr>
-                        <a:defRPr sz="1150">
-                          <a:latin typeface="Arial"/>
-                        </a:defRPr>
-                      </a:pPr>
                       <a:r>
-                        <a:t>Length 3 windows (~1.0 s)</a:t>
-                      </a:r>
-                    </a:p>
-                  </a:txBody>
-                  <a:tcPr/>
-                </a:tc>
-                <a:tc>
-                  <a:txBody>
-                    <a:bodyPr/>
-                    <a:lstStyle/>
-                    <a:p>
-                      <a:pPr>
-                        <a:defRPr sz="1150">
-                          <a:latin typeface="Arial"/>
-                        </a:defRPr>
-                      </a:pPr>
-                      <a:r>
-                        <a:t>Directly matches windowed ERD latency</a:t>
-                      </a:r>
-                    </a:p>
-                  </a:txBody>
-                  <a:tcPr/>
-                </a:tc>
-              </a:tr>
-              <a:tr h="396240">
-                <a:tc>
-                  <a:txBody>
-                    <a:bodyPr/>
-                    <a:lstStyle/>
-                    <a:p>
-                      <a:pPr>
-                        <a:defRPr sz="1150">
-                          <a:latin typeface="Arial"/>
-                        </a:defRPr>
-                      </a:pPr>
-                      <a:r>
-                        <a:t>GPU Training Time</a:t>
-                      </a:r>
-                    </a:p>
-                  </a:txBody>
-                  <a:tcPr/>
-                </a:tc>
-                <a:tc>
-                  <a:txBody>
-                    <a:bodyPr/>
-                    <a:lstStyle/>
-                    <a:p>
-                      <a:pPr>
-                        <a:defRPr sz="1150">
-                          <a:latin typeface="Arial"/>
-                        </a:defRPr>
-                      </a:pPr>
-                      <a:r>
-                        <a:t>~18 minutes (9 subjects)</a:t>
-                      </a:r>
-                    </a:p>
-                  </a:txBody>
-                  <a:tcPr/>
-                </a:tc>
-                <a:tc>
-                  <a:txBody>
-                    <a:bodyPr/>
-                    <a:lstStyle/>
-                    <a:p>
-                      <a:pPr>
-                        <a:defRPr sz="1150" b="1">
-                          <a:latin typeface="Arial"/>
-                        </a:defRPr>
-                      </a:pPr>
-                      <a:r>
-                        <a:t>~4.5 minutes (9 subjects)</a:t>
-                      </a:r>
-                    </a:p>
-                  </a:txBody>
-                  <a:tcPr/>
-                </a:tc>
-                <a:tc>
-                  <a:txBody>
-                    <a:bodyPr/>
-                    <a:lstStyle/>
-                    <a:p>
-                      <a:pPr>
-                        <a:defRPr sz="1150">
-                          <a:latin typeface="Arial"/>
-                        </a:defRPr>
-                      </a:pPr>
-                      <a:r>
-                        <a:t>4x faster training and iteration</a:t>
+                        <a:rPr sz="1600"/>
+                        <a:t>~4.5 min</a:t>
                       </a:r>
                     </a:p>
                   </a:txBody>
@@ -4582,8 +3675,8 @@
         </p:nvSpPr>
         <p:spPr>
           <a:xfrm>
-            <a:off x="731520" y="4297680"/>
-            <a:ext cx="10698480" cy="2011680"/>
+            <a:off x="841248" y="4389120"/>
+            <a:ext cx="10515600" cy="1645920"/>
           </a:xfrm>
           <a:prstGeom prst="rect">
             <a:avLst/>
@@ -4596,67 +3689,27 @@
           </a:bodyPr>
           <a:lstStyle/>
           <a:p>
-            <a:pPr>
+            <a:pPr marL="274320" indent="-274320" lvl="0">
               <a:spcBef>
-                <a:spcPts val="0"/>
+                <a:spcPts val="600"/>
               </a:spcBef>
-              <a:defRPr sz="1500" b="1">
-                <a:solidFill>
-                  <a:srgbClr val="1E1E1E"/>
-                </a:solidFill>
-                <a:latin typeface="Arial"/>
-              </a:defRPr>
+              <a:buChar char="•"/>
             </a:pPr>
             <a:r>
-              <a:t>Takeaways from comparison:</a:t>
-            </a:r>
-          </a:p>
-          <a:p>
-            <a:pPr lvl="1">
+              <a:rPr b="0" sz="1800"/>
+              <a:t>Preprocessing already extracts the spatial-spectral information, so the autoencoder and triplet loss in MixNet are not needed</a:t>
+            </a:r>
+          </a:p>
+          <a:p>
+            <a:pPr marL="274320" indent="-274320" lvl="0">
               <a:spcBef>
-                <a:spcPts val="500"/>
+                <a:spcPts val="600"/>
               </a:spcBef>
-              <a:defRPr sz="1350" b="0">
-                <a:solidFill>
-                  <a:srgbClr val="5A5A5A"/>
-                </a:solidFill>
-                <a:latin typeface="Arial"/>
-              </a:defRPr>
+              <a:buChar char="•"/>
             </a:pPr>
             <a:r>
-              <a:t>MixNet relies on autoencoder reconstruction and triplet metric learning to regularize high-capacity CNNs.</a:t>
-            </a:r>
-          </a:p>
-          <a:p>
-            <a:pPr lvl="1">
-              <a:spcBef>
-                <a:spcPts val="500"/>
-              </a:spcBef>
-              <a:defRPr sz="1350" b="0">
-                <a:solidFill>
-                  <a:srgbClr val="5A5A5A"/>
-                </a:solidFill>
-                <a:latin typeface="Arial"/>
-              </a:defRPr>
-            </a:pPr>
-            <a:r>
-              <a:t>Because HW_prep already extracts high-level spectral and spatial power envelopes, HWNet does not need an autoencoder.</a:t>
-            </a:r>
-          </a:p>
-          <a:p>
-            <a:pPr lvl="1">
-              <a:spcBef>
-                <a:spcPts val="500"/>
-              </a:spcBef>
-              <a:defRPr sz="1350" b="0">
-                <a:solidFill>
-                  <a:srgbClr val="5A5A5A"/>
-                </a:solidFill>
-                <a:latin typeface="Arial"/>
-              </a:defRPr>
-            </a:pPr>
-            <a:r>
-              <a:t>A lightweight, regularized CNN achieves superior generalization on small datasets.</a:t>
+              <a:rPr b="0" sz="1800"/>
+              <a:t>Fewer parameters and a single loss: nothing to balance or tune</a:t>
             </a:r>
           </a:p>
         </p:txBody>
@@ -4672,14 +3725,6 @@
 <file path=ppt/slides/slide5.xml><?xml version="1.0" encoding="utf-8"?>
 <p:sld xmlns:a="http://schemas.openxmlformats.org/drawingml/2006/main" xmlns:p="http://schemas.openxmlformats.org/presentationml/2006/main" xmlns:r="http://schemas.openxmlformats.org/officeDocument/2006/relationships">
   <p:cSld>
-    <p:bg>
-      <p:bgPr>
-        <a:solidFill>
-          <a:srgbClr val="FFFFFF"/>
-        </a:solidFill>
-        <a:effectLst/>
-      </p:bgPr>
-    </p:bg>
     <p:spTree>
       <p:nvGrpSpPr>
         <p:cNvPr id="1" name=""/>
@@ -4689,52 +3734,21 @@
       <p:grpSpPr/>
       <p:sp>
         <p:nvSpPr>
-          <p:cNvPr id="2" name="TextBox 1"/>
-          <p:cNvSpPr txBox="1"/>
-          <p:nvPr/>
-        </p:nvSpPr>
-        <p:spPr>
-          <a:xfrm>
-            <a:off x="731520" y="457200"/>
-            <a:ext cx="10698480" cy="1005840"/>
-          </a:xfrm>
-          <a:prstGeom prst="rect">
-            <a:avLst/>
-          </a:prstGeom>
-          <a:noFill/>
-        </p:spPr>
-        <p:txBody>
-          <a:bodyPr wrap="square" lIns="0" tIns="0" rIns="0" bIns="0">
-            <a:spAutoFit/>
-          </a:bodyPr>
-          <a:lstStyle/>
-          <a:p>
-            <a:pPr>
-              <a:defRPr sz="1100" b="1">
-                <a:solidFill>
-                  <a:srgbClr val="5A5A5A"/>
-                </a:solidFill>
-                <a:latin typeface="Arial"/>
-              </a:defRPr>
-            </a:pPr>
-            <a:r>
-              <a:t>PART 2 &amp; 3: MODEL ARCHITECTURE &amp; EVALUATION</a:t>
-            </a:r>
-          </a:p>
-          <a:p>
-            <a:pPr>
-              <a:spcBef>
-                <a:spcPts val="400"/>
-              </a:spcBef>
-              <a:defRPr sz="2400" b="1">
-                <a:solidFill>
-                  <a:srgbClr val="1E1E1E"/>
-                </a:solidFill>
-                <a:latin typeface="Arial"/>
-              </a:defRPr>
-            </a:pPr>
-            <a:r>
-              <a:t>Benchmark Results on Held-Out Test Set (Session E)</a:t>
+          <p:cNvPr id="2" name="Title 1"/>
+          <p:cNvSpPr>
+            <a:spLocks noGrp="1"/>
+          </p:cNvSpPr>
+          <p:nvPr>
+            <p:ph type="title"/>
+          </p:nvPr>
+        </p:nvSpPr>
+        <p:spPr/>
+        <p:txBody>
+          <a:bodyPr/>
+          <a:lstStyle/>
+          <a:p>
+            <a:r>
+              <a:t>Results on Held-Out Session E</a:t>
             </a:r>
           </a:p>
         </p:txBody>
@@ -4748,8 +3762,8 @@
           <p:nvPr/>
         </p:nvGraphicFramePr>
         <p:xfrm>
-          <a:off x="731520" y="1645920"/>
-          <a:ext cx="10698480" cy="1371600"/>
+          <a:off x="841248" y="1554480"/>
+          <a:ext cx="10515600" cy="1097280"/>
         </p:xfrm>
         <a:graphic>
           <a:graphicData uri="http://schemas.openxmlformats.org/drawingml/2006/table">
@@ -4758,132 +3772,20 @@
                 <a:tableStyleId>{5C22544A-7EE6-4342-B048-85BDC9FD1C3A}</a:tableStyleId>
               </a:tblPr>
               <a:tblGrid>
-                <a:gridCol w="2286000"/>
-                <a:gridCol w="2011680"/>
-                <a:gridCol w="2194560"/>
-                <a:gridCol w="2011680"/>
-                <a:gridCol w="2194560"/>
+                <a:gridCol w="2377440"/>
+                <a:gridCol w="2834640"/>
+                <a:gridCol w="2834640"/>
+                <a:gridCol w="2468880"/>
               </a:tblGrid>
-              <a:tr h="457200">
+              <a:tr h="365760">
                 <a:tc>
                   <a:txBody>
                     <a:bodyPr/>
                     <a:lstStyle/>
                     <a:p>
-                      <a:pPr>
-                        <a:defRPr b="1" sz="1200">
-                          <a:latin typeface="Arial"/>
-                        </a:defRPr>
-                      </a:pPr>
                       <a:r>
+                        <a:rPr sz="1600"/>
                         <a:t>Model</a:t>
-                      </a:r>
-                    </a:p>
-                  </a:txBody>
-                  <a:tcPr>
-                    <a:solidFill>
-                      <a:srgbClr val="F5F5F5"/>
-                    </a:solidFill>
-                  </a:tcPr>
-                </a:tc>
-                <a:tc>
-                  <a:txBody>
-                    <a:bodyPr/>
-                    <a:lstStyle/>
-                    <a:p>
-                      <a:pPr>
-                        <a:defRPr b="1" sz="1200">
-                          <a:latin typeface="Arial"/>
-                        </a:defRPr>
-                      </a:pPr>
-                      <a:r>
-                        <a:t>Test Accuracy (Mean)</a:t>
-                      </a:r>
-                    </a:p>
-                  </a:txBody>
-                  <a:tcPr>
-                    <a:solidFill>
-                      <a:srgbClr val="F5F5F5"/>
-                    </a:solidFill>
-                  </a:tcPr>
-                </a:tc>
-                <a:tc>
-                  <a:txBody>
-                    <a:bodyPr/>
-                    <a:lstStyle/>
-                    <a:p>
-                      <a:pPr>
-                        <a:defRPr b="1" sz="1200">
-                          <a:latin typeface="Arial"/>
-                        </a:defRPr>
-                      </a:pPr>
-                      <a:r>
-                        <a:t>Accuracy Std Dev</a:t>
-                      </a:r>
-                    </a:p>
-                  </a:txBody>
-                  <a:tcPr>
-                    <a:solidFill>
-                      <a:srgbClr val="F5F5F5"/>
-                    </a:solidFill>
-                  </a:tcPr>
-                </a:tc>
-                <a:tc>
-                  <a:txBody>
-                    <a:bodyPr/>
-                    <a:lstStyle/>
-                    <a:p>
-                      <a:pPr>
-                        <a:defRPr b="1" sz="1200">
-                          <a:latin typeface="Arial"/>
-                        </a:defRPr>
-                      </a:pPr>
-                      <a:r>
-                        <a:t>Macro F1 (Mean)</a:t>
-                      </a:r>
-                    </a:p>
-                  </a:txBody>
-                  <a:tcPr>
-                    <a:solidFill>
-                      <a:srgbClr val="F5F5F5"/>
-                    </a:solidFill>
-                  </a:tcPr>
-                </a:tc>
-                <a:tc>
-                  <a:txBody>
-                    <a:bodyPr/>
-                    <a:lstStyle/>
-                    <a:p>
-                      <a:pPr>
-                        <a:defRPr b="1" sz="1200">
-                          <a:latin typeface="Arial"/>
-                        </a:defRPr>
-                      </a:pPr>
-                      <a:r>
-                        <a:t>Trainable Params</a:t>
-                      </a:r>
-                    </a:p>
-                  </a:txBody>
-                  <a:tcPr>
-                    <a:solidFill>
-                      <a:srgbClr val="F5F5F5"/>
-                    </a:solidFill>
-                  </a:tcPr>
-                </a:tc>
-              </a:tr>
-              <a:tr h="457200">
-                <a:tc>
-                  <a:txBody>
-                    <a:bodyPr/>
-                    <a:lstStyle/>
-                    <a:p>
-                      <a:pPr>
-                        <a:defRPr sz="1200">
-                          <a:latin typeface="Arial"/>
-                        </a:defRPr>
-                      </a:pPr>
-                      <a:r>
-                        <a:t>MixNet (Baseline)</a:t>
                       </a:r>
                     </a:p>
                   </a:txBody>
@@ -4894,13 +3796,9 @@
                     <a:bodyPr/>
                     <a:lstStyle/>
                     <a:p>
-                      <a:pPr>
-                        <a:defRPr sz="1200">
-                          <a:latin typeface="Arial"/>
-                        </a:defRPr>
-                      </a:pPr>
                       <a:r>
-                        <a:t>76.53%</a:t>
+                        <a:rPr sz="1600"/>
+                        <a:t>Accuracy (mean ± SD)</a:t>
                       </a:r>
                     </a:p>
                   </a:txBody>
@@ -4911,13 +3809,9 @@
                     <a:bodyPr/>
                     <a:lstStyle/>
                     <a:p>
-                      <a:pPr>
-                        <a:defRPr sz="1200">
-                          <a:latin typeface="Arial"/>
-                        </a:defRPr>
-                      </a:pPr>
                       <a:r>
-                        <a:t>+/- 15.10%</a:t>
+                        <a:rPr sz="1600"/>
+                        <a:t>Macro F1 (mean ± SD)</a:t>
                       </a:r>
                     </a:p>
                   </a:txBody>
@@ -4928,13 +3822,24 @@
                     <a:bodyPr/>
                     <a:lstStyle/>
                     <a:p>
-                      <a:pPr>
-                        <a:defRPr sz="1200">
-                          <a:latin typeface="Arial"/>
-                        </a:defRPr>
-                      </a:pPr>
                       <a:r>
-                        <a:t>0.7532</a:t>
+                        <a:rPr sz="1600"/>
+                        <a:t>Trainable params</a:t>
+                      </a:r>
+                    </a:p>
+                  </a:txBody>
+                  <a:tcPr/>
+                </a:tc>
+              </a:tr>
+              <a:tr h="365760">
+                <a:tc>
+                  <a:txBody>
+                    <a:bodyPr/>
+                    <a:lstStyle/>
+                    <a:p>
+                      <a:r>
+                        <a:rPr sz="1600"/>
+                        <a:t>MixNet</a:t>
                       </a:r>
                     </a:p>
                   </a:txBody>
@@ -4945,32 +3850,9 @@
                     <a:bodyPr/>
                     <a:lstStyle/>
                     <a:p>
-                      <a:pPr>
-                        <a:defRPr sz="1200">
-                          <a:latin typeface="Arial"/>
-                        </a:defRPr>
-                      </a:pPr>
                       <a:r>
-                        <a:t>44,777</a:t>
-                      </a:r>
-                    </a:p>
-                  </a:txBody>
-                  <a:tcPr/>
-                </a:tc>
-              </a:tr>
-              <a:tr h="457200">
-                <a:tc>
-                  <a:txBody>
-                    <a:bodyPr/>
-                    <a:lstStyle/>
-                    <a:p>
-                      <a:pPr>
-                        <a:defRPr sz="1200" b="1">
-                          <a:latin typeface="Arial"/>
-                        </a:defRPr>
-                      </a:pPr>
-                      <a:r>
-                        <a:t>HWNet (Ours)</a:t>
+                        <a:rPr sz="1600"/>
+                        <a:t>76.53% ± 15.10%</a:t>
                       </a:r>
                     </a:p>
                   </a:txBody>
@@ -4981,13 +3863,9 @@
                     <a:bodyPr/>
                     <a:lstStyle/>
                     <a:p>
-                      <a:pPr>
-                        <a:defRPr sz="1200" b="1">
-                          <a:latin typeface="Arial"/>
-                        </a:defRPr>
-                      </a:pPr>
                       <a:r>
-                        <a:t>77.13%</a:t>
+                        <a:rPr sz="1600"/>
+                        <a:t>0.753 ± 0.164</a:t>
                       </a:r>
                     </a:p>
                   </a:txBody>
@@ -4998,13 +3876,24 @@
                     <a:bodyPr/>
                     <a:lstStyle/>
                     <a:p>
-                      <a:pPr>
-                        <a:defRPr sz="1200" b="1">
-                          <a:latin typeface="Arial"/>
-                        </a:defRPr>
-                      </a:pPr>
                       <a:r>
-                        <a:t>+/- 15.02%</a:t>
+                        <a:rPr sz="1600"/>
+                        <a:t>44,777</a:t>
+                      </a:r>
+                    </a:p>
+                  </a:txBody>
+                  <a:tcPr/>
+                </a:tc>
+              </a:tr>
+              <a:tr h="365760">
+                <a:tc>
+                  <a:txBody>
+                    <a:bodyPr/>
+                    <a:lstStyle/>
+                    <a:p>
+                      <a:r>
+                        <a:rPr sz="1600"/>
+                        <a:t>HWNet</a:t>
                       </a:r>
                     </a:p>
                   </a:txBody>
@@ -5015,13 +3904,9 @@
                     <a:bodyPr/>
                     <a:lstStyle/>
                     <a:p>
-                      <a:pPr>
-                        <a:defRPr sz="1200" b="1">
-                          <a:latin typeface="Arial"/>
-                        </a:defRPr>
-                      </a:pPr>
                       <a:r>
-                        <a:t>0.7572</a:t>
+                        <a:rPr sz="1600"/>
+                        <a:t>77.13% ± 15.02%</a:t>
                       </a:r>
                     </a:p>
                   </a:txBody>
@@ -5032,13 +3917,22 @@
                     <a:bodyPr/>
                     <a:lstStyle/>
                     <a:p>
-                      <a:pPr>
-                        <a:defRPr sz="1200" b="1">
-                          <a:latin typeface="Arial"/>
-                        </a:defRPr>
-                      </a:pPr>
                       <a:r>
-                        <a:t>5,362 (~8x fewer)</a:t>
+                        <a:rPr sz="1600"/>
+                        <a:t>0.757 ± 0.174</a:t>
+                      </a:r>
+                    </a:p>
+                  </a:txBody>
+                  <a:tcPr/>
+                </a:tc>
+                <a:tc>
+                  <a:txBody>
+                    <a:bodyPr/>
+                    <a:lstStyle/>
+                    <a:p>
+                      <a:r>
+                        <a:rPr sz="1600"/>
+                        <a:t>5,362</a:t>
                       </a:r>
                     </a:p>
                   </a:txBody>
@@ -5057,8 +3951,8 @@
         </p:nvSpPr>
         <p:spPr>
           <a:xfrm>
-            <a:off x="731520" y="3291840"/>
-            <a:ext cx="10698480" cy="3017520"/>
+            <a:off x="841248" y="3108960"/>
+            <a:ext cx="10515600" cy="3108960"/>
           </a:xfrm>
           <a:prstGeom prst="rect">
             <a:avLst/>
@@ -5071,131 +3965,51 @@
           </a:bodyPr>
           <a:lstStyle/>
           <a:p>
-            <a:pPr>
-              <a:spcBef>
-                <a:spcPts val="0"/>
-              </a:spcBef>
-              <a:defRPr sz="1500" b="1">
-                <a:solidFill>
-                  <a:srgbClr val="1E1E1E"/>
-                </a:solidFill>
-                <a:latin typeface="Arial"/>
-              </a:defRPr>
-            </a:pPr>
-            <a:r>
-              <a:t>Key Benchmark Observations:</a:t>
-            </a:r>
-          </a:p>
-          <a:p>
-            <a:pPr lvl="1">
+            <a:pPr marL="274320" indent="-274320" lvl="0">
               <a:spcBef>
                 <a:spcPts val="600"/>
               </a:spcBef>
-              <a:defRPr sz="1350" b="0">
-                <a:solidFill>
-                  <a:srgbClr val="5A5A5A"/>
-                </a:solidFill>
-                <a:latin typeface="Arial"/>
-              </a:defRPr>
+              <a:buChar char="•"/>
             </a:pPr>
             <a:r>
-              <a:t>Evaluation protocol: Subject-dependent 5-fold CV on Session T, evaluated on held-out Session E.</a:t>
-            </a:r>
-          </a:p>
-          <a:p>
-            <a:pPr lvl="1">
+              <a:rPr b="0" sz="2000"/>
+              <a:t>Protocol: 5-fold CV on Session T, tested on unseen Session E, 9 subjects</a:t>
+            </a:r>
+          </a:p>
+          <a:p>
+            <a:pPr marL="274320" indent="-274320" lvl="0">
               <a:spcBef>
                 <a:spcPts val="600"/>
               </a:spcBef>
-              <a:defRPr sz="1350" b="0">
-                <a:solidFill>
-                  <a:srgbClr val="5A5A5A"/>
-                </a:solidFill>
-                <a:latin typeface="Arial"/>
-              </a:defRPr>
+              <a:buChar char="•"/>
             </a:pPr>
             <a:r>
-              <a:t>HWNet outperforms MixNet in both mean accuracy (77.13% vs. 76.53%) and macro F1 (0.7572 vs. 0.7532).</a:t>
-            </a:r>
-          </a:p>
-          <a:p>
-            <a:pPr lvl="1">
+              <a:rPr b="0" sz="2000"/>
+              <a:t>HWNet: +0.6 pp accuracy, better on 4 of 9 subjects</a:t>
+            </a:r>
+          </a:p>
+          <a:p>
+            <a:pPr marL="274320" indent="-274320" lvl="0">
               <a:spcBef>
                 <a:spcPts val="600"/>
               </a:spcBef>
-              <a:defRPr sz="1350" b="0">
-                <a:solidFill>
-                  <a:srgbClr val="5A5A5A"/>
-                </a:solidFill>
-                <a:latin typeface="Arial"/>
-              </a:defRPr>
+              <a:buChar char="•"/>
             </a:pPr>
             <a:r>
-              <a:t>Wins on 4 out of 9 subjects, with notable improvements on low-accuracy subjects.</a:t>
-            </a:r>
-          </a:p>
-          <a:p>
-            <a:pPr lvl="1">
+              <a:rPr b="0" sz="2000"/>
+              <a:t>Difference is not significant (paired t-test p = 0.787, Wilcoxon p = 0.734)</a:t>
+            </a:r>
+          </a:p>
+          <a:p>
+            <a:pPr marL="274320" indent="-274320" lvl="0">
               <a:spcBef>
                 <a:spcPts val="600"/>
               </a:spcBef>
-              <a:defRPr sz="1350" b="0">
-                <a:solidFill>
-                  <a:srgbClr val="5A5A5A"/>
-                </a:solidFill>
-                <a:latin typeface="Arial"/>
-              </a:defRPr>
+              <a:buChar char="•"/>
             </a:pPr>
             <a:r>
-              <a:t>Statistical significance tests across 9 subjects:</a:t>
-            </a:r>
-          </a:p>
-          <a:p>
-            <a:pPr lvl="2">
-              <a:spcBef>
-                <a:spcPts val="300"/>
-              </a:spcBef>
-              <a:defRPr sz="1350" b="0">
-                <a:solidFill>
-                  <a:srgbClr val="5A5A5A"/>
-                </a:solidFill>
-                <a:latin typeface="Arial"/>
-              </a:defRPr>
-            </a:pPr>
-            <a:r>
-              <a:t>Paired t-test: t = 0.2800, p = 0.7866</a:t>
-            </a:r>
-          </a:p>
-          <a:p>
-            <a:pPr lvl="2">
-              <a:spcBef>
-                <a:spcPts val="300"/>
-              </a:spcBef>
-              <a:defRPr sz="1350" b="0">
-                <a:solidFill>
-                  <a:srgbClr val="5A5A5A"/>
-                </a:solidFill>
-                <a:latin typeface="Arial"/>
-              </a:defRPr>
-            </a:pPr>
-            <a:r>
-              <a:t>Wilcoxon signed-rank test: W = 19.0000, p = 0.7344</a:t>
-            </a:r>
-          </a:p>
-          <a:p>
-            <a:pPr lvl="1">
-              <a:spcBef>
-                <a:spcPts val="600"/>
-              </a:spcBef>
-              <a:defRPr sz="1350" b="0">
-                <a:solidFill>
-                  <a:srgbClr val="5A5A5A"/>
-                </a:solidFill>
-                <a:latin typeface="Arial"/>
-              </a:defRPr>
-            </a:pPr>
-            <a:r>
-              <a:t>Conclusion: HWNet matches/exceeds MixNet performance while cutting model size by ~8x.</a:t>
+              <a:rPr b="0" sz="2000"/>
+              <a:t>Takeaway: same accuracy as MixNet with ~8× fewer parameters and 4× faster training</a:t>
             </a:r>
           </a:p>
         </p:txBody>
@@ -5211,14 +4025,6 @@
 <file path=ppt/slides/slide6.xml><?xml version="1.0" encoding="utf-8"?>
 <p:sld xmlns:a="http://schemas.openxmlformats.org/drawingml/2006/main" xmlns:p="http://schemas.openxmlformats.org/presentationml/2006/main" xmlns:r="http://schemas.openxmlformats.org/officeDocument/2006/relationships">
   <p:cSld>
-    <p:bg>
-      <p:bgPr>
-        <a:solidFill>
-          <a:srgbClr val="FFFFFF"/>
-        </a:solidFill>
-        <a:effectLst/>
-      </p:bgPr>
-    </p:bg>
     <p:spTree>
       <p:nvGrpSpPr>
         <p:cNvPr id="1" name=""/>
@@ -5228,219 +4034,86 @@
       <p:grpSpPr/>
       <p:sp>
         <p:nvSpPr>
-          <p:cNvPr id="2" name="TextBox 1"/>
-          <p:cNvSpPr txBox="1"/>
-          <p:nvPr/>
-        </p:nvSpPr>
-        <p:spPr>
-          <a:xfrm>
-            <a:off x="731520" y="457200"/>
-            <a:ext cx="10698480" cy="1005840"/>
-          </a:xfrm>
-          <a:prstGeom prst="rect">
-            <a:avLst/>
-          </a:prstGeom>
-          <a:noFill/>
-        </p:spPr>
-        <p:txBody>
-          <a:bodyPr wrap="square" lIns="0" tIns="0" rIns="0" bIns="0">
-            <a:spAutoFit/>
-          </a:bodyPr>
-          <a:lstStyle/>
-          <a:p>
-            <a:pPr>
-              <a:defRPr sz="1100" b="1">
-                <a:solidFill>
-                  <a:srgbClr val="5A5A5A"/>
-                </a:solidFill>
-                <a:latin typeface="Arial"/>
-              </a:defRPr>
-            </a:pPr>
-            <a:r>
-              <a:t>PART 2 &amp; 3: MODEL ARCHITECTURE &amp; EVALUATION</a:t>
-            </a:r>
-          </a:p>
-          <a:p>
-            <a:pPr>
-              <a:spcBef>
-                <a:spcPts val="400"/>
-              </a:spcBef>
-              <a:defRPr sz="2400" b="1">
-                <a:solidFill>
-                  <a:srgbClr val="1E1E1E"/>
-                </a:solidFill>
-                <a:latin typeface="Arial"/>
-              </a:defRPr>
-            </a:pPr>
-            <a:r>
-              <a:t>Per-Subject Analysis &amp; Neurophysiological Insights</a:t>
-            </a:r>
-          </a:p>
-        </p:txBody>
-      </p:sp>
-      <p:sp>
-        <p:nvSpPr>
-          <p:cNvPr id="3" name="TextBox 2"/>
-          <p:cNvSpPr txBox="1"/>
-          <p:nvPr/>
-        </p:nvSpPr>
-        <p:spPr>
-          <a:xfrm>
-            <a:off x="731520" y="1645920"/>
-            <a:ext cx="10698480" cy="4572000"/>
-          </a:xfrm>
-          <a:prstGeom prst="rect">
-            <a:avLst/>
-          </a:prstGeom>
-          <a:noFill/>
-        </p:spPr>
-        <p:txBody>
-          <a:bodyPr wrap="square">
-            <a:spAutoFit/>
-          </a:bodyPr>
-          <a:lstStyle/>
-          <a:p>
-            <a:pPr>
-              <a:spcBef>
-                <a:spcPts val="0"/>
-              </a:spcBef>
-              <a:defRPr sz="1500" b="1">
-                <a:solidFill>
-                  <a:srgbClr val="1E1E1E"/>
-                </a:solidFill>
-                <a:latin typeface="Arial"/>
-              </a:defRPr>
-            </a:pPr>
-            <a:r>
-              <a:t>Where HWNet Outperforms MixNet:</a:t>
-            </a:r>
-          </a:p>
-          <a:p>
-            <a:pPr lvl="1">
-              <a:spcBef>
-                <a:spcPts val="600"/>
-              </a:spcBef>
-              <a:defRPr sz="1350" b="1">
-                <a:solidFill>
-                  <a:srgbClr val="5A5A5A"/>
-                </a:solidFill>
-                <a:latin typeface="Arial"/>
-              </a:defRPr>
-            </a:pPr>
-            <a:r>
-              <a:t>Subject 5: 76.81% vs. 60.83% (+15.98% gain)</a:t>
-            </a:r>
-          </a:p>
-          <a:p>
-            <a:pPr lvl="2">
-              <a:spcBef>
-                <a:spcPts val="300"/>
-              </a:spcBef>
-              <a:defRPr sz="1350" b="0">
-                <a:solidFill>
-                  <a:srgbClr val="5A5A5A"/>
-                </a:solidFill>
-                <a:latin typeface="Arial"/>
-              </a:defRPr>
-            </a:pPr>
-            <a:r>
-              <a:t>S05 exhibits brief, late-onset ERD. MixNet's global averaging diluted this signal, while HWNet's 0.5 s sliding windows captured the peak modulation cleanly.</a:t>
-            </a:r>
-          </a:p>
-          <a:p>
-            <a:pPr lvl="1">
-              <a:spcBef>
-                <a:spcPts val="600"/>
-              </a:spcBef>
-              <a:defRPr sz="1350" b="1">
-                <a:solidFill>
-                  <a:srgbClr val="5A5A5A"/>
-                </a:solidFill>
-                <a:latin typeface="Arial"/>
-              </a:defRPr>
-            </a:pPr>
-            <a:r>
-              <a:t>Subject 8: 93.47% vs. 90.42% (+3.05% gain) -- Top performing subject in the cohort.</a:t>
-            </a:r>
-          </a:p>
-          <a:p>
-            <a:pPr lvl="1">
-              <a:spcBef>
-                <a:spcPts val="600"/>
-              </a:spcBef>
-              <a:defRPr sz="1350" b="1">
-                <a:solidFill>
-                  <a:srgbClr val="5A5A5A"/>
-                </a:solidFill>
-                <a:latin typeface="Arial"/>
-              </a:defRPr>
-            </a:pPr>
-            <a:r>
-              <a:t>Subject 3: 92.22% vs. 91.94% (+0.28% gain) -- Near-ceiling bilateral discrimination.</a:t>
-            </a:r>
-          </a:p>
-          <a:p>
-            <a:pPr>
-              <a:spcBef>
-                <a:spcPts val="1400"/>
-              </a:spcBef>
-              <a:defRPr sz="1500" b="1">
-                <a:solidFill>
-                  <a:srgbClr val="1E1E1E"/>
-                </a:solidFill>
-                <a:latin typeface="Arial"/>
-              </a:defRPr>
-            </a:pPr>
-            <a:r>
-              <a:t>The Challenge of BCI Inefficiency (Subject 2):</a:t>
-            </a:r>
-          </a:p>
-          <a:p>
-            <a:pPr lvl="1">
-              <a:spcBef>
-                <a:spcPts val="600"/>
-              </a:spcBef>
-              <a:defRPr sz="1350" b="0">
-                <a:solidFill>
-                  <a:srgbClr val="5A5A5A"/>
-                </a:solidFill>
-                <a:latin typeface="Arial"/>
-              </a:defRPr>
-            </a:pPr>
-            <a:r>
-              <a:t>Subject 2 scored near chance level on both models (HWNet: 49.44%, MixNet: 55.14%).</a:t>
-            </a:r>
-          </a:p>
-          <a:p>
-            <a:pPr lvl="2">
-              <a:spcBef>
-                <a:spcPts val="300"/>
-              </a:spcBef>
-              <a:defRPr sz="1350" b="0">
-                <a:solidFill>
-                  <a:srgbClr val="5A5A5A"/>
-                </a:solidFill>
-                <a:latin typeface="Arial"/>
-              </a:defRPr>
-            </a:pPr>
-            <a:r>
-              <a:t>Neurophysiological context: 15-30% of human subjects exhibit 'BCI inefficiency / illiteracy' (inability to produce distinct mu/beta desynchronization over sensorimotor cortex).</a:t>
-            </a:r>
-          </a:p>
-          <a:p>
-            <a:pPr lvl="1">
-              <a:spcBef>
-                <a:spcPts val="600"/>
-              </a:spcBef>
-              <a:defRPr sz="1350" b="0">
-                <a:solidFill>
-                  <a:srgbClr val="5A5A5A"/>
-                </a:solidFill>
-                <a:latin typeface="Arial"/>
-              </a:defRPr>
-            </a:pPr>
-            <a:r>
-              <a:t>Excluding Subject 2, HWNet achieves an average test accuracy of 80.59%.</a:t>
+          <p:cNvPr id="2" name="Title 1"/>
+          <p:cNvSpPr>
+            <a:spLocks noGrp="1"/>
+          </p:cNvSpPr>
+          <p:nvPr>
+            <p:ph type="title"/>
+          </p:nvPr>
+        </p:nvSpPr>
+        <p:spPr/>
+        <p:txBody>
+          <a:bodyPr/>
+          <a:lstStyle/>
+          <a:p>
+            <a:r>
+              <a:t>Per-Subject Observations</a:t>
+            </a:r>
+          </a:p>
+        </p:txBody>
+      </p:sp>
+      <p:sp>
+        <p:nvSpPr>
+          <p:cNvPr id="3" name="Content Placeholder 2"/>
+          <p:cNvSpPr>
+            <a:spLocks noGrp="1"/>
+          </p:cNvSpPr>
+          <p:nvPr>
+            <p:ph idx="1"/>
+          </p:nvPr>
+        </p:nvSpPr>
+        <p:spPr/>
+        <p:txBody>
+          <a:bodyPr/>
+          <a:lstStyle/>
+          <a:p>
+            <a:pPr/>
+            <a:r>
+              <a:rPr b="0" sz="2200"/>
+              <a:t>Largest gain on S5: 76.81% vs. 60.83% (+16.0 pp)</a:t>
+            </a:r>
+          </a:p>
+          <a:p>
+            <a:pPr lvl="1"/>
+            <a:r>
+              <a:rPr b="0" sz="1900"/>
+              <a:t>S5 shows a brief, late ERD; the 0.5 s windows likely capture it better than MixNet's long kernels</a:t>
+            </a:r>
+          </a:p>
+          <a:p>
+            <a:pPr/>
+            <a:r>
+              <a:rPr b="0" sz="2200"/>
+              <a:t>S8: 93.47% vs. 90.42%, best subject in the cohort</a:t>
+            </a:r>
+          </a:p>
+          <a:p>
+            <a:pPr/>
+            <a:r>
+              <a:rPr b="0" sz="2200"/>
+              <a:t>S3: 92.22% vs. 91.94%, near ceiling for both models</a:t>
+            </a:r>
+          </a:p>
+          <a:p>
+            <a:pPr/>
+            <a:r>
+              <a:rPr b="0" sz="2200"/>
+              <a:t>S2 is near chance for both models (HWNet 49.44%, MixNet 55.14%)</a:t>
+            </a:r>
+          </a:p>
+          <a:p>
+            <a:pPr lvl="1"/>
+            <a:r>
+              <a:rPr b="0" sz="1900"/>
+              <a:t>Consistent with BCI inefficiency: no clear μ/β desynchronisation</a:t>
+            </a:r>
+          </a:p>
+          <a:p>
+            <a:pPr lvl="1"/>
+            <a:r>
+              <a:rPr b="0" sz="1900"/>
+              <a:t>Excluding S2, HWNet mean accuracy is 80.59%</a:t>
             </a:r>
           </a:p>
         </p:txBody>
@@ -5456,14 +4129,6 @@
 <file path=ppt/slides/slide7.xml><?xml version="1.0" encoding="utf-8"?>
 <p:sld xmlns:a="http://schemas.openxmlformats.org/drawingml/2006/main" xmlns:p="http://schemas.openxmlformats.org/presentationml/2006/main" xmlns:r="http://schemas.openxmlformats.org/officeDocument/2006/relationships">
   <p:cSld>
-    <p:bg>
-      <p:bgPr>
-        <a:solidFill>
-          <a:srgbClr val="FFFFFF"/>
-        </a:solidFill>
-        <a:effectLst/>
-      </p:bgPr>
-    </p:bg>
     <p:spTree>
       <p:nvGrpSpPr>
         <p:cNvPr id="1" name=""/>
@@ -5473,50 +4138,19 @@
       <p:grpSpPr/>
       <p:sp>
         <p:nvSpPr>
-          <p:cNvPr id="2" name="TextBox 1"/>
-          <p:cNvSpPr txBox="1"/>
-          <p:nvPr/>
-        </p:nvSpPr>
-        <p:spPr>
-          <a:xfrm>
-            <a:off x="731520" y="457200"/>
-            <a:ext cx="10698480" cy="1005840"/>
-          </a:xfrm>
-          <a:prstGeom prst="rect">
-            <a:avLst/>
-          </a:prstGeom>
-          <a:noFill/>
-        </p:spPr>
-        <p:txBody>
-          <a:bodyPr wrap="square" lIns="0" tIns="0" rIns="0" bIns="0">
-            <a:spAutoFit/>
-          </a:bodyPr>
-          <a:lstStyle/>
-          <a:p>
-            <a:pPr>
-              <a:defRPr sz="1100" b="1">
-                <a:solidFill>
-                  <a:srgbClr val="5A5A5A"/>
-                </a:solidFill>
-                <a:latin typeface="Arial"/>
-              </a:defRPr>
-            </a:pPr>
-            <a:r>
-              <a:t>PART 2 &amp; 3: MODEL ARCHITECTURE &amp; EVALUATION</a:t>
-            </a:r>
-          </a:p>
-          <a:p>
-            <a:pPr>
-              <a:spcBef>
-                <a:spcPts val="400"/>
-              </a:spcBef>
-              <a:defRPr sz="2400" b="1">
-                <a:solidFill>
-                  <a:srgbClr val="1E1E1E"/>
-                </a:solidFill>
-                <a:latin typeface="Arial"/>
-              </a:defRPr>
-            </a:pPr>
+          <p:cNvPr id="2" name="Title 1"/>
+          <p:cNvSpPr>
+            <a:spLocks noGrp="1"/>
+          </p:cNvSpPr>
+          <p:nvPr>
+            <p:ph type="title"/>
+          </p:nvPr>
+        </p:nvSpPr>
+        <p:spPr/>
+        <p:txBody>
+          <a:bodyPr/>
+          <a:lstStyle/>
+          <a:p>
             <a:r>
               <a:t>Conclusion</a:t>
             </a:r>
@@ -5525,103 +4159,44 @@
       </p:sp>
       <p:sp>
         <p:nvSpPr>
-          <p:cNvPr id="3" name="TextBox 2"/>
-          <p:cNvSpPr txBox="1"/>
-          <p:nvPr/>
-        </p:nvSpPr>
-        <p:spPr>
-          <a:xfrm>
-            <a:off x="731520" y="1645920"/>
-            <a:ext cx="10698480" cy="4572000"/>
-          </a:xfrm>
-          <a:prstGeom prst="rect">
-            <a:avLst/>
-          </a:prstGeom>
-          <a:noFill/>
-        </p:spPr>
-        <p:txBody>
-          <a:bodyPr wrap="square">
-            <a:spAutoFit/>
-          </a:bodyPr>
-          <a:lstStyle/>
-          <a:p>
-            <a:pPr>
-              <a:spcBef>
-                <a:spcPts val="0"/>
-              </a:spcBef>
-              <a:defRPr sz="1500" b="1">
-                <a:solidFill>
-                  <a:srgbClr val="1E1E1E"/>
-                </a:solidFill>
-                <a:latin typeface="Arial"/>
-              </a:defRPr>
-            </a:pPr>
-            <a:r>
-              <a:t>Summary of Findings:</a:t>
-            </a:r>
-          </a:p>
-          <a:p>
-            <a:pPr lvl="1">
-              <a:spcBef>
-                <a:spcPts val="800"/>
-              </a:spcBef>
-              <a:defRPr sz="1350" b="0">
-                <a:solidFill>
-                  <a:srgbClr val="5A5A5A"/>
-                </a:solidFill>
-                <a:latin typeface="Arial"/>
-              </a:defRPr>
-            </a:pPr>
-            <a:r>
-              <a:t>Preprocessing does the heavy lifting: Converting raw EEG to windowed FBCSP log-variance (36, 15) preserves temporal ERD/ERS without dimensionality bloat.</a:t>
-            </a:r>
-          </a:p>
-          <a:p>
-            <a:pPr lvl="1">
-              <a:spcBef>
-                <a:spcPts val="800"/>
-              </a:spcBef>
-              <a:defRPr sz="1350" b="0">
-                <a:solidFill>
-                  <a:srgbClr val="5A5A5A"/>
-                </a:solidFill>
-                <a:latin typeface="Arial"/>
-              </a:defRPr>
-            </a:pPr>
-            <a:r>
-              <a:t>Compact architecture is optimal for EEG: A 2-block temporal CNN with 5,362 parameters avoids overfitting on small-sample training folds (~115 trials).</a:t>
-            </a:r>
-          </a:p>
-          <a:p>
-            <a:pPr lvl="1">
-              <a:spcBef>
-                <a:spcPts val="800"/>
-              </a:spcBef>
-              <a:defRPr sz="1350" b="0">
-                <a:solidFill>
-                  <a:srgbClr val="5A5A5A"/>
-                </a:solidFill>
-                <a:latin typeface="Arial"/>
-              </a:defRPr>
-            </a:pPr>
-            <a:r>
-              <a:t>Superior performance with 8x parameter reduction: HWNet reaches 77.13% test accuracy on Session E, beating MixNet's 76.53%.</a:t>
-            </a:r>
-          </a:p>
-          <a:p>
-            <a:pPr lvl="1">
-              <a:spcBef>
-                <a:spcPts val="800"/>
-              </a:spcBef>
-              <a:defRPr sz="1350" b="0">
-                <a:solidFill>
-                  <a:srgbClr val="5A5A5A"/>
-                </a:solidFill>
-                <a:latin typeface="Arial"/>
-              </a:defRPr>
-            </a:pPr>
-            <a:r>
-              <a:t>Practical efficiency: 4x faster training (~4.5 mins for all 9 subjects) and zero auxiliary loss tuning.</a:t>
+          <p:cNvPr id="3" name="Content Placeholder 2"/>
+          <p:cNvSpPr>
+            <a:spLocks noGrp="1"/>
+          </p:cNvSpPr>
+          <p:nvPr>
+            <p:ph idx="1"/>
+          </p:nvPr>
+        </p:nvSpPr>
+        <p:spPr/>
+        <p:txBody>
+          <a:bodyPr/>
+          <a:lstStyle/>
+          <a:p>
+            <a:pPr/>
+            <a:r>
+              <a:rPr b="0" sz="2400"/>
+              <a:t>Windowed FBCSP features (36 × 15) keep the temporal ERD/ERS information in a compact form</a:t>
+            </a:r>
+          </a:p>
+          <a:p>
+            <a:pPr/>
+            <a:r>
+              <a:rPr b="0" sz="2400"/>
+              <a:t>A 2-block temporal CNN with 5.4k parameters is enough on top of these features</a:t>
+            </a:r>
+          </a:p>
+          <a:p>
+            <a:pPr/>
+            <a:r>
+              <a:rPr b="0" sz="2400"/>
+              <a:t>Matches MixNet on Session E (77.13% vs. 76.53%, n.s.) with ~8× fewer parameters</a:t>
+            </a:r>
+          </a:p>
+          <a:p>
+            <a:pPr/>
+            <a:r>
+              <a:rPr b="0" sz="2400"/>
+              <a:t>Faster to train (~4.5 min for all subjects) and no auxiliary losses to tune</a:t>
             </a:r>
           </a:p>
         </p:txBody>

</xml_diff>